<commit_message>
Deck: remove em-dashes, sentence-case bodies (less 'AI-generated' feel)
- tidy()/_dash() helpers applied in bullets, takeaway, titles, dividers, diagram
  labels and notes: em/en dashes -> commas; bullet bodies sentence-cased.
- Technical tokens preserved (dbt, event_id, ingest_page_views.py, REVOPS_*,
  hyphen/dot bases like dbt-owned).
- Sub-bullet glyph en-dash -> middle dot; slide-3 layer labels use ':'; fixed
  title/footer/divider/code-box-title copy. Result: 0 em/en dashes in the deck.

Co-Authored-By: Claude Opus 4.8 (1M context) <noreply@anthropic.com>
</commit_message>
<xml_diff>
--- a/presentation/OpenGov_Data_Platform_CaseStudy.pptx
+++ b/presentation/OpenGov_Data_Platform_CaseStudy.pptx
@@ -529,7 +529,7 @@
           <a:lstStyle/>
           <a:p>
             <a:r>
-              <a:t>Open with the thesis: I build the factory — the governed foundation that lets every domain team ship analytics and AI on top, safely and fast. Today I'll walk foundation -&gt; pipelines -&gt; self-service -&gt; trust &amp; governance, then close with a forward-looking bet on making the platform AI-ready.</a:t>
+              <a:t>Open with the thesis: I build the factory, the governed foundation that lets every domain team ship analytics and AI on top, safely and fast. Today I'll walk foundation -&gt; pipelines -&gt; self-service -&gt; trust &amp; governance, then close with a forward-looking bet on making the platform AI-ready.</a:t>
             </a:r>
           </a:p>
         </p:txBody>
@@ -599,7 +599,7 @@
           <a:lstStyle/>
           <a:p>
             <a:r>
-              <a:t>Snowflake's recommended two-tier model: access roles hold object privileges; functional roles (job-based) inherit access roles; users get functional roles. Why it scales: access roles are reusable primitives, so a 10th domain is a generated set of roles — no bespoke grant spaghetti. Service accounts get their own functional roles (dbt vs human analyst). Row-access policies enforce tenant/region isolation on shared tables. This exact model is what I build in Part 2.</a:t>
+              <a:t>Snowflake's recommended two-tier model: access roles hold object privileges; functional roles (job-based) inherit access roles; users get functional roles. Why it scales: access roles are reusable primitives, so a 10th domain is a generated set of roles, no bespoke grant spaghetti. Service accounts get their own functional roles (dbt vs human analyst). Row-access policies enforce tenant/region isolation on shared tables. This exact model is what I build in Part 2.</a:t>
             </a:r>
           </a:p>
         </p:txBody>
@@ -739,7 +739,7 @@
           <a:lstStyle/>
           <a:p>
             <a:r>
-              <a:t>This is my point of view. The trap everyone is walking into: pointing LLMs at raw warehouses. Without a semantic layer, the model guesses join logic and metric definitions — confidently wrong. Solution: a governed metrics/semantic layer as the single interface for humans AND AI, plus data contracts enforced in CI so definitions can't silently drift. Crucially, Snowflake's masking/row policies apply to the LLM's service account — governance isn't bypassed by AI. This is how OpenGov gets trustworthy AI, not just more AI.</a:t>
+              <a:t>This is my point of view. The trap everyone is walking into: pointing LLMs at raw warehouses. Without a semantic layer, the model guesses join logic and metric definitions, confidently wrong. Solution: a governed metrics/semantic layer as the single interface for humans AND AI, plus data contracts enforced in CI so definitions can't silently drift. Crucially, Snowflake's masking/row policies apply to the LLM's service account, governance isn't bypassed by AI. This is how OpenGov gets trustworthy AI, not just more AI.</a:t>
             </a:r>
           </a:p>
         </p:txBody>
@@ -809,7 +809,7 @@
           <a:lstStyle/>
           <a:p>
             <a:r>
-              <a:t>Orient the panel: this is the same architecture, now real. Each bullet is a deliverable I can open live. Emphasize config-driven + CI-deployed — no click-ops.</a:t>
+              <a:t>Orient the panel: this is the same architecture, now real. Each bullet is a deliverable I can open live. Emphasize config-driven + CI-deployed, no click-ops.</a:t>
             </a:r>
           </a:p>
         </p:txBody>
@@ -879,7 +879,7 @@
           <a:lstStyle/>
           <a:p>
             <a:r>
-              <a:t>Walk each layer: ingestion roles are scoped to exactly their landing schema (Fivetran owns its DDL; the ADLS loader is DML-only against a platform-owned contract). Shared STAGING/MARTS are written ONLY by REVOPS_DEVELOPER through the dbt CI job — no human holds that role. Readers read all; analysts read marts; a domain analyst is scoped to that domain's marts (FINANCE_ANALYST in the appendix).</a:t>
+              <a:t>Walk each layer: ingestion roles are scoped to exactly their landing schema (Fivetran owns its DDL; the ADLS loader is DML-only against a platform-owned contract). Shared STAGING/MARTS are written ONLY by REVOPS_DEVELOPER through the dbt CI job, no human holds that role. Readers read all; analysts read marts; a domain analyst is scoped to that domain's marts (FINANCE_ANALYST in the appendix).</a:t>
             </a:r>
           </a:p>
         </p:txBody>
@@ -1019,7 +1019,7 @@
           <a:lstStyle/>
           <a:p>
             <a:r>
-              <a:t>This is the brief's ingestion task, 1:1 — only S3 became ADLS (owner decision, boto3 pattern ported to the Azure Blob SDK). The null-user_id record from the sample payload is exactly what the quarantine catches. Partial-batch: good rows commit, bad rows quarantine, never fail the whole file. Lambda-on-arrival and a second event type (config-driven) are the extension answers.</a:t>
+              <a:t>This is the brief's ingestion task, 1:1, only S3 became ADLS (owner decision, boto3 pattern ported to the Azure Blob SDK). The null-user_id record from the sample payload is exactly what the quarantine catches. Partial-batch: good rows commit, bad rows quarantine, never fail the whole file. Lambda-on-arrival and a second event type (config-driven) are the extension answers.</a:t>
             </a:r>
           </a:p>
         </p:txBody>
@@ -1089,7 +1089,7 @@
           <a:lstStyle/>
           <a:p>
             <a:r>
-              <a:t>Native dbt on Snowflake: the repo runs as a DBT PROJECT object, executed in-account as REVOPS_DEVELOPER — the CI runner never builds models. Incremental vs full-refresh is the volume decision (appendix). mart_revops__pipeline is the mesh public model.</a:t>
+              <a:t>Native dbt on Snowflake: the repo runs as a DBT PROJECT object, executed in-account as REVOPS_DEVELOPER, the CI runner never builds models. Incremental vs full-refresh is the volume decision (appendix). mart_revops__pipeline is the mesh public model.</a:t>
             </a:r>
           </a:p>
         </p:txBody>
@@ -1229,7 +1229,7 @@
           <a:lstStyle/>
           <a:p>
             <a:r>
-              <a:t>This is the 'paved path' for a person. The composite role is the key design: read everything, write only your sandbox, one role active — no secondary-role ambiguity. Onboarding is a two-line PR (demonstrated live with AKASHPAHILWAN, SOURABH_SHINDE, ANUJKUMAR).</a:t>
+              <a:t>This is the 'paved path' for a person. The composite role is the key design: read everything, write only your sandbox, one role active, no secondary-role ambiguity. Onboarding is a two-line PR (demonstrated live with AKASHPAHILWAN, SOURABH_SHINDE, ANUJKUMAR).</a:t>
             </a:r>
           </a:p>
         </p:txBody>
@@ -1299,7 +1299,7 @@
           <a:lstStyle/>
           <a:p>
             <a:r>
-              <a:t>Frame the role: a platform engineer's customer is other engineers/analysts. The job is to make the right thing the easy thing. Stress federation with guardrails — central team owns the paved path, domains own their data products. These four principles recur on every later slide.</a:t>
+              <a:t>Frame the role: a platform engineer's customer is other engineers/analysts. The job is to make the right thing the easy thing. Stress federation with guardrails, central team owns the paved path, domains own their data products. These four principles recur on every later slide.</a:t>
             </a:r>
           </a:p>
         </p:txBody>
@@ -1369,7 +1369,7 @@
           <a:lstStyle/>
           <a:p>
             <a:r>
-              <a:t>Land the thesis: platform-as-product, governed by default, self-service, running end-to-end. Invite deep-dive questions — the appendix has the internals.</a:t>
+              <a:t>Land the thesis: platform-as-product, governed by default, self-service, running end-to-end. Invite deep-dive questions, the appendix has the internals.</a:t>
             </a:r>
           </a:p>
         </p:txBody>
@@ -1439,7 +1439,7 @@
           <a:lstStyle/>
           <a:p>
             <a:r>
-              <a:t>Direct answer to 'how does this scale to 10 domains + how do you handle service vs human + audit'. The FINANCE_ANALYST demo is the concrete proof of domain-scoped least privilege — built and verified live.</a:t>
+              <a:t>Direct answer to 'how does this scale to 10 domains + how do you handle service vs human + audit'. The FINANCE_ANALYST demo is the concrete proof of domain-scoped least privilege, built and verified live.</a:t>
             </a:r>
           </a:p>
         </p:txBody>
@@ -1649,7 +1649,7 @@
           <a:lstStyle/>
           <a:p>
             <a:r>
-              <a:t>BONUS / HIDDEN — pull up only if the panel digs into VARIANT performance. Key message: VARIANT is not a JSON string column. On write, Snowflake examines paths that occur consistently across rows in a micro-partition and stores each as its own typed, compressed sub-column with min/max metadata — so path projection and partition pruning behave like native columns. It degrades only when keys are wildly inconsistent row-to-row; the fix is promoting hot keys (event_id) to real columns, which we do anyway for dedup. Drift behavior: missing key reads as NULL (never an error), new keys are invisible until a PR selects them, and TRY_CAST + dbt tests turn type drift into a quarantine signal instead of a failed job. 16 MB/value limit is ~4 orders of magnitude above a telemetry event. One-breath close: 'stable RAW DDL, columnarized paths, type once in incremental staging — downstream never touches JSON.'</a:t>
+              <a:t>BONUS / HIDDEN, pull up only if the panel digs into VARIANT performance. Key message: VARIANT is not a JSON string column. On write, Snowflake examines paths that occur consistently across rows in a micro-partition and stores each as its own typed, compressed sub-column with min/max metadata, so path projection and partition pruning behave like native columns. It degrades only when keys are wildly inconsistent row-to-row; the fix is promoting hot keys (event_id) to real columns, which we do anyway for dedup. Drift behavior: missing key reads as NULL (never an error), new keys are invisible until a PR selects them, and TRY_CAST + dbt tests turn type drift into a quarantine signal instead of a failed job. 16 MB/value limit is ~4 orders of magnitude above a telemetry event. One-breath close: 'stable RAW DDL, columnarized paths, type once in incremental staging, downstream never touches JSON.'</a:t>
             </a:r>
           </a:p>
         </p:txBody>
@@ -1719,7 +1719,7 @@
           <a:lstStyle/>
           <a:p>
             <a:r>
-              <a:t>BONUS / HIDDEN — pull up if asked about bucket layout, hourly cadence, or 'why not Snowpipe'. Hive-style dt=/hr= prefixes sort lexicographically by time, so the watermark is just the last processed prefix; re-scan a trailing 24-48h window so late-arriving files in an old hour still load (COPY's file history dedups the overlap for free). Append-only stance: never 'replace with latest' — RAW keeps every loaded row; dedup and current-state are computed in staging (QUALIFY on event_id). Snowpipe question: for the case-study deliverable I keep a scheduled Python job + COPY, because the assessed logic — schema validation, quarantine, _LOAD_LOG summary — lives in that code, and hourly batch on an XS warehouse is cheap. In production, with files landing continuously, I'd flip to Snowpipe: S3 event notification -&gt; per-file auto-ingest, exactly-once per file, ~1-minute latency, no scheduler or watermark logic at all; validation then moves to a post-load stream/task. Same table, same append-only contract — only the trigger changes. 64-day detail: COPY's per-file load history EXPIRES after 64 days. A backfill touching older files is silently SKIPPED by default (status unknown -&gt; skip, no error — a silent gap, not duplicates). Deliberate old backfill: set LOAD_UNCERTAIN_FILES=TRUE (staging's event_id dedup absorbs any repeats) or FORCE=TRUE into a fresh table + SWAP. This expiry is exactly why the design has three layers — COPY history expires, a watermark can miss late files, so event_id dedup in staging is the backstop that never expires.</a:t>
+              <a:t>BONUS / HIDDEN, pull up if asked about bucket layout, hourly cadence, or 'why not Snowpipe'. Hive-style dt=/hr= prefixes sort lexicographically by time, so the watermark is just the last processed prefix; re-scan a trailing 24-48h window so late-arriving files in an old hour still load (COPY's file history dedups the overlap for free). Append-only stance: never 'replace with latest', RAW keeps every loaded row; dedup and current-state are computed in staging (QUALIFY on event_id). Snowpipe question: for the case-study deliverable I keep a scheduled Python job + COPY, because the assessed logic, schema validation, quarantine, _LOAD_LOG summary, lives in that code, and hourly batch on an XS warehouse is cheap. In production, with files landing continuously, I'd flip to Snowpipe: S3 event notification -&gt; per-file auto-ingest, exactly-once per file, ~1-minute latency, no scheduler or watermark logic at all; validation then moves to a post-load stream/task. Same table, same append-only contract, only the trigger changes. 64-day detail: COPY's per-file load history EXPIRES after 64 days. A backfill touching older files is silently SKIPPED by default (status unknown -&gt; skip, no error, a silent gap, not duplicates). Deliberate old backfill: set LOAD_UNCERTAIN_FILES=TRUE (staging's event_id dedup absorbs any repeats) or FORCE=TRUE into a fresh table + SWAP. This expiry is exactly why the design has three layers, COPY history expires, a watermark can miss late files, so event_id dedup in staging is the backstop that never expires.</a:t>
             </a:r>
           </a:p>
         </p:txBody>
@@ -1789,7 +1789,7 @@
           <a:lstStyle/>
           <a:p>
             <a:r>
-              <a:t>BONUS / HIDDEN — pull up for 'can we see what COPY loaded?' or the 64-day follow-up. Three observable layers: (1) COPY INTO itself returns a result set — one row per file with status, rows_parsed, rows_loaded, errors_seen, first_error — and the Part 2 Python job captures exactly this into _LOAD_LOG, which is the brief's load-summary requirement and lives forever. (2) COPY_HISTORY / LOAD_HISTORY: INFORMATION_SCHEMA table functions keep 14 days per table; SNOWFLAKE.ACCOUNT_USAGE views keep 365 days account-wide with up to ~90 min latency — these are audit/observability surfaces. (3) Distinct from both: the internal per-file dedup metadata COPY consults to skip already-loaded files — 64-day lifetime, not directly queryable. Beyond 64 days the load status is 'unknown' and COPY silently SKIPS the file by default (gap, not duplicates); deliberate backfills set LOAD_UNCERTAIN_FILES=TRUE and let staging's event_id dedup absorb repeats, or rebuild with FORCE=TRUE + SWAP. Close with the three-layer line: history expires, watermarks miss late files, staging dedup never expires.</a:t>
+              <a:t>BONUS / HIDDEN, pull up for 'can we see what COPY loaded?' or the 64-day follow-up. Three observable layers: (1) COPY INTO itself returns a result set, one row per file with status, rows_parsed, rows_loaded, errors_seen, first_error, and the Part 2 Python job captures exactly this into _LOAD_LOG, which is the brief's load-summary requirement and lives forever. (2) COPY_HISTORY / LOAD_HISTORY: INFORMATION_SCHEMA table functions keep 14 days per table; SNOWFLAKE.ACCOUNT_USAGE views keep 365 days account-wide with up to ~90 min latency, these are audit/observability surfaces. (3) Distinct from both: the internal per-file dedup metadata COPY consults to skip already-loaded files, 64-day lifetime, not directly queryable. Beyond 64 days the load status is 'unknown' and COPY silently SKIPS the file by default (gap, not duplicates); deliberate backfills set LOAD_UNCERTAIN_FILES=TRUE and let staging's event_id dedup absorb repeats, or rebuild with FORCE=TRUE + SWAP. Close with the three-layer line: history expires, watermarks miss late files, staging dedup never expires.</a:t>
             </a:r>
           </a:p>
         </p:txBody>
@@ -1859,7 +1859,7 @@
           <a:lstStyle/>
           <a:p>
             <a:r>
-              <a:t>This is the anchor diagram — walk it left to right. Sources land via Fivetran (connectorized SaaS) or a custom Python path on AWS (S3 + Lambda) for telemetry and bespoke APIs. Everything lands in Snowflake RAW, then dbt promotes RAW→STAGING→MARTS, with SANDBOX for exploration. Consumers are BI, AI/ML + LLM/RAG, and reverse ETL. The navy band is the cross-cutting foundation that every layer sits on: IaC, RBAC+masking, observability, CI/CD. Invite the 'why Fivetran here, Lambda there' question — next slide answers it.</a:t>
+              <a:t>This is the anchor diagram, walk it left to right. Sources land via Fivetran (connectorized SaaS) or a custom Python path on AWS (S3 + Lambda) for telemetry and bespoke APIs. Everything lands in Snowflake RAW, then dbt promotes RAW→STAGING→MARTS, with SANDBOX for exploration. Consumers are BI, AI/ML + LLM/RAG, and reverse ETL. The navy band is the cross-cutting foundation that every layer sits on: IaC, RBAC+masking, observability, CI/CD. Invite the 'why Fivetran here, Lambda there' question, next slide answers it.</a:t>
             </a:r>
           </a:p>
         </p:txBody>
@@ -1929,7 +1929,7 @@
           <a:lstStyle/>
           <a:p>
             <a:r>
-              <a:t>The decision rule: buy vs build on control, cost curve, and whether a reliable connector exists. Fivetran wins for SaaS — someone else maintains the connector and absorbs API changes. Telemetry is the opposite: huge volume, simple shape, cost at Fivetran's per-row pricing would be brutal, and we want near-real-time via S3 events → Lambda. So we own that path. Be ready to defend the cost math.</a:t>
+              <a:t>The decision rule: buy vs build on control, cost curve, and whether a reliable connector exists. Fivetran wins for SaaS, someone else maintains the connector and absorbs API changes. Telemetry is the opposite: huge volume, simple shape, cost at Fivetran's per-row pricing would be brutal, and we want near-real-time via S3 events → Lambda. So we own that path. Be ready to defend the cost math.</a:t>
             </a:r>
           </a:p>
         </p:txBody>
@@ -1999,7 +1999,7 @@
           <a:lstStyle/>
           <a:p>
             <a:r>
-              <a:t>This directly answers 'we deploy objects via CI/CD — how does drift fit?'. Separate the two schemas. The SOURCE shape is uncontrolled and can change any time; OUR objects are code and change only via a reviewed, tested PR. RAW uses a VARIANT column so upstream additions need no DDL and never break a load — CI/CD does not run on every upstream change. Drift is detected against a contract and surfaced (additive) or quarantined + alerted (breaking), but never auto-alters a deployed table. To make a new field real, an engineer adds one typed column in dbt via a PR; contracts + tests run in CI as the tripwire. Fivetran is the contrast: it is schema-on-WRITE — it types columns and ALTERs its own RAW tables when the source drifts — so the read-time boundary moves one layer down: dbt sources select only the columns we depend on, and the source contract + tests fail CI before bad data flows downstream. Crisp framing if pushed: schema-on-read is a property of the RAW layer. In the custom path we own RAW, so we land VARIANT and type late; in the Fivetran path Fivetran owns and evolves RAW, so our read-time contract is the dbt source. Either way, a new field enters the deployed model only through a reviewed PR. Use CREATE OR ALTER / additive, idempotent migrations so redeploys are safe on half-failures.</a:t>
+              <a:t>This directly answers 'we deploy objects via CI/CD, how does drift fit?'. Separate the two schemas. The SOURCE shape is uncontrolled and can change any time; OUR objects are code and change only via a reviewed, tested PR. RAW uses a VARIANT column so upstream additions need no DDL and never break a load, CI/CD does not run on every upstream change. Drift is detected against a contract and surfaced (additive) or quarantined + alerted (breaking), but never auto-alters a deployed table. To make a new field real, an engineer adds one typed column in dbt via a PR; contracts + tests run in CI as the tripwire. Fivetran is the contrast: it is schema-on-WRITE, it types columns and ALTERs its own RAW tables when the source drifts, so the read-time boundary moves one layer down: dbt sources select only the columns we depend on, and the source contract + tests fail CI before bad data flows downstream. Crisp framing if pushed: schema-on-read is a property of the RAW layer. In the custom path we own RAW, so we land VARIANT and type late; in the Fivetran path Fivetran owns and evolves RAW, so our read-time contract is the dbt source. Either way, a new field enters the deployed model only through a reviewed PR. Use CREATE OR ALTER / additive, idempotent migrations so redeploys are safe on half-failures.</a:t>
             </a:r>
           </a:p>
         </p:txBody>
@@ -2069,7 +2069,7 @@
           <a:lstStyle/>
           <a:p>
             <a:r>
-              <a:t>RAW is the system of record — never mutate it. Partition for replay and cheap pruning. The quarantine + load-log pattern gives operability: you can always answer 'did the 09:00 file land, and how many rows did we reject?' This maps one-to-one to the PAGE_VIEWS ingestion I build in Part 2, including the intentional null user_id record that gets quarantined.</a:t>
+              <a:t>RAW is the system of record, never mutate it. Partition for replay and cheap pruning. The quarantine + load-log pattern gives operability: you can always answer 'did the 09:00 file land, and how many rows did we reject?' This maps one-to-one to the PAGE_VIEWS ingestion I build in Part 2, including the intentional null user_id record that gets quarantined.</a:t>
             </a:r>
           </a:p>
         </p:txBody>
@@ -2209,7 +2209,7 @@
           <a:lstStyle/>
           <a:p>
             <a:r>
-              <a:t>The 1-to-10-domains question lives here. Answer: don't grow one monolith — split by domain with clear ownership, and use dbt Mesh contracts as the interface between domains. Public models are the API; internals can refactor freely. Incremental vs full-refresh is a volume/cost decision. Mention mart_revops__pipeline (Part 2) would be exposed as a PUBLIC contracted model.</a:t>
+              <a:t>The 1-to-10-domains question lives here. Answer: don't grow one monolith, split by domain with clear ownership, and use dbt Mesh contracts as the interface between domains. Public models are the API; internals can refactor freely. Incremental vs full-refresh is a volume/cost decision. Mention mart_revops__pipeline (Part 2) would be exposed as a PUBLIC contracted model.</a:t>
             </a:r>
           </a:p>
         </p:txBody>
@@ -2279,7 +2279,7 @@
           <a:lstStyle/>
           <a:p>
             <a:r>
-              <a:t>This is the 'factory' payoff and a differentiator vs teams that hand-craft each domain. A single opinionated Terraform module encodes all standards, so every new domain is born compliant. Teams self-serve via PR; the platform team reviews the module, not every request. This is how RBAC actually scales to 10 domains — it's generated, not hand-written.</a:t>
+              <a:t>This is the 'factory' payoff and a differentiator vs teams that hand-craft each domain. A single opinionated Terraform module encodes all standards, so every new domain is born compliant. Teams self-serve via PR; the platform team reviews the module, not every request. This is how RBAC actually scales to 10 domains, it's generated, not hand-written.</a:t>
             </a:r>
           </a:p>
         </p:txBody>
@@ -5422,7 +5422,7 @@
                 </a:solidFill>
                 <a:latin typeface="Segoe UI"/>
               </a:rPr>
-              <a:t>Case Study — Viewpoint</a:t>
+              <a:t>Case Study Presentation</a:t>
             </a:r>
           </a:p>
           <a:p>
@@ -6800,7 +6800,7 @@
                 </a:solidFill>
                 <a:latin typeface="Segoe UI"/>
               </a:rPr>
-              <a:t>Access roles are reused building blocks; add a domain = generate a new set — grants never sprawl.  Row-access policies handle multi-tenant isolation.</a:t>
+              <a:t>Access roles are reused building blocks; add a domain = generate a new set, grants never sprawl.  Row-access policies handle multi-tenant isolation.</a:t>
             </a:r>
           </a:p>
         </p:txBody>
@@ -6834,7 +6834,7 @@
                 </a:solidFill>
                 <a:latin typeface="Segoe UI"/>
               </a:rPr>
-              <a:t>OpenGov Data Platform  ·  Case Study — Viewpoint  ·  Akash Pahilwan</a:t>
+              <a:t>OpenGov Data Platform  ·  Case Study  ·  Akash Pahilwan</a:t>
             </a:r>
           </a:p>
         </p:txBody>
@@ -7033,7 +7033,7 @@
                 </a:solidFill>
                 <a:latin typeface="Segoe UI"/>
               </a:rPr>
-              <a:t>Observability — what we built</a:t>
+              <a:t>Observability, what we built</a:t>
             </a:r>
           </a:p>
         </p:txBody>
@@ -7108,7 +7108,7 @@
                 </a:solidFill>
                 <a:latin typeface="Segoe UI"/>
               </a:rPr>
-              <a:t>Load observability — PAGE_VIEWS_LOAD_LOG:   </a:t>
+              <a:t>Load observability, PAGE_VIEWS_LOAD_LOG:   </a:t>
             </a:r>
             <a:r>
               <a:rPr sz="1600">
@@ -7117,7 +7117,7 @@
                 </a:solidFill>
                 <a:latin typeface="Segoe UI"/>
               </a:rPr>
-              <a:t>one row per ingestion run (file, records loaded, quarantined, timestamp) — an audit trail that outlives COPY's 64-day history.</a:t>
+              <a:t>One row per ingestion run (file, records loaded, quarantined, timestamp), an audit trail that outlives COPY's 64-day history.</a:t>
             </a:r>
           </a:p>
           <a:p>
@@ -7154,7 +7154,7 @@
                 </a:solidFill>
                 <a:latin typeface="Segoe UI"/>
               </a:rPr>
-              <a:t>bad rows land in PAGE_VIEWS_QUARANTINE, countable per run (PROD: 9 loaded / 5 quarantined) — a reject-rate you can alert on.</a:t>
+              <a:t>Bad rows land in PAGE_VIEWS_QUARANTINE, countable per run (PROD: 9 loaded / 5 quarantined), a reject-rate you can alert on.</a:t>
             </a:r>
           </a:p>
           <a:p>
@@ -7191,7 +7191,7 @@
                 </a:solidFill>
                 <a:latin typeface="Segoe UI"/>
               </a:rPr>
-              <a:t>dbt not_null / unique / accepted_values / relationships run on every preprod &amp; prod build — a red test blocks the deploy.</a:t>
+              <a:t>dbt not_null / unique / accepted_values / relationships run on every preprod &amp; prod build, a red test blocks the deploy.</a:t>
             </a:r>
           </a:p>
           <a:p>
@@ -7265,7 +7265,7 @@
                 </a:solidFill>
                 <a:latin typeface="Segoe UI"/>
               </a:rPr>
-              <a:t>per-role warehouses (OG_&lt;ENV&gt;_&lt;ROLE&gt;_WH) + auto-suspend — spend is attributable to reader / analyst / dbt / ingestion, not one shared blob.</a:t>
+              <a:t>Per-role warehouses (OG_&lt;ENV&gt;_&lt;ROLE&gt;_WH) + auto-suspend, spend is attributable to reader / analyst / dbt / ingestion, not one shared blob.</a:t>
             </a:r>
           </a:p>
           <a:p>
@@ -7433,7 +7433,7 @@
                 </a:solidFill>
                 <a:latin typeface="Segoe UI"/>
               </a:rPr>
-              <a:t>We built the observable primitives — a per-file load log, a quarantine table, CI-gated tests, and native audit views — so 'did the load run and was it clean?' is a query, not a guess.</a:t>
+              <a:t>We built the observable primitives, a per-file load log, a quarantine table, CI-gated tests, and native audit views, so 'did the load run and was it clean?' is a query, not a guess.</a:t>
             </a:r>
           </a:p>
         </p:txBody>
@@ -7467,7 +7467,7 @@
                 </a:solidFill>
                 <a:latin typeface="Segoe UI"/>
               </a:rPr>
-              <a:t>OpenGov Data Platform  ·  Case Study — Viewpoint  ·  Akash Pahilwan</a:t>
+              <a:t>OpenGov Data Platform  ·  Case Study  ·  Akash Pahilwan</a:t>
             </a:r>
           </a:p>
         </p:txBody>
@@ -7787,7 +7787,7 @@
                 </a:solidFill>
                 <a:latin typeface="Segoe UI"/>
               </a:rPr>
-              <a:t>define metrics once (revenue, pipeline, churn) → one source of truth for BI, notebooks, and LLMs.</a:t>
+              <a:t>Define metrics once (revenue, pipeline, churn) → one source of truth for BI, notebooks, and LLMs.</a:t>
             </a:r>
           </a:p>
           <a:p>
@@ -7824,7 +7824,7 @@
                 </a:solidFill>
                 <a:latin typeface="Segoe UI"/>
               </a:rPr>
-              <a:t>producers commit to schema + semantics; breaking changes are blocked in CI — trust shifts left.</a:t>
+              <a:t>Producers commit to schema + semantics; breaking changes are blocked in CI, trust shifts left.</a:t>
             </a:r>
           </a:p>
           <a:p>
@@ -7861,7 +7861,7 @@
                 </a:solidFill>
                 <a:latin typeface="Segoe UI"/>
               </a:rPr>
-              <a:t>RAG and agents read documented, contracted marts + the semantic layer — never RAW.</a:t>
+              <a:t>RAG and agents read documented, contracted marts + the semantic layer, never RAW.</a:t>
             </a:r>
           </a:p>
           <a:p>
@@ -7889,7 +7889,7 @@
                 </a:solidFill>
                 <a:latin typeface="Segoe UI"/>
               </a:rPr>
-              <a:t>Governance already travels — true in this build:   </a:t>
+              <a:t>Governance already travels, true in this build:   </a:t>
             </a:r>
             <a:r>
               <a:rPr sz="1700">
@@ -7898,7 +7898,7 @@
                 </a:solidFill>
                 <a:latin typeface="Segoe UI"/>
               </a:rPr>
-              <a:t>our tag-masking + RBAC bind to the SESSION, not the tool. An LLM service account holding REVOPS_READER gets NULL for ARR today, exactly like a human reader — there is no AI bypass to build.</a:t>
+              <a:t>Our tag-masking + RBAC bind to the SESSION, not the tool. An LLM service account holding REVOPS_READER gets NULL for ARR today, exactly like a human reader, there is no AI bypass to build.</a:t>
             </a:r>
           </a:p>
         </p:txBody>
@@ -8029,7 +8029,7 @@
                 </a:solidFill>
                 <a:latin typeface="Segoe UI"/>
               </a:rPr>
-              <a:t>Trustworthy AI and trustworthy analytics come from the same governed foundation — the semantic layer is the interface.</a:t>
+              <a:t>Trustworthy AI and trustworthy analytics come from the same governed foundation, the semantic layer is the interface.</a:t>
             </a:r>
           </a:p>
         </p:txBody>
@@ -8063,7 +8063,7 @@
                 </a:solidFill>
                 <a:latin typeface="Segoe UI"/>
               </a:rPr>
-              <a:t>OpenGov Data Platform  ·  Case Study — Viewpoint  ·  Akash Pahilwan</a:t>
+              <a:t>OpenGov Data Platform  ·  Case Study  ·  Akash Pahilwan</a:t>
             </a:r>
           </a:p>
         </p:txBody>
@@ -8226,7 +8226,7 @@
                 </a:solidFill>
                 <a:latin typeface="Segoe UI"/>
               </a:rPr>
-              <a:t>Part 2 — Hands-On Build: RevOps, built &amp; running</a:t>
+              <a:t>Part 2: Hands-On Build</a:t>
             </a:r>
           </a:p>
           <a:p>
@@ -8242,7 +8242,7 @@
                 </a:solidFill>
                 <a:latin typeface="Segoe UI"/>
               </a:rPr>
-              <a:t>The paved path, made real: RBAC + masking · ADLS ingestion · dbt marts · CI/CD — all live in Snowflake.</a:t>
+              <a:t>RevOps, built and running. RBAC and masking, ADLS ingestion, dbt marts, and CI/CD, all live in Snowflake.</a:t>
             </a:r>
           </a:p>
         </p:txBody>
@@ -8406,7 +8406,7 @@
                 </a:solidFill>
                 <a:latin typeface="Segoe UI"/>
               </a:rPr>
-              <a:t>RevOps onboarded — the four deliverables, live</a:t>
+              <a:t>RevOps onboarded, the four deliverables, live</a:t>
             </a:r>
           </a:p>
         </p:txBody>
@@ -8490,7 +8490,7 @@
                 </a:solidFill>
                 <a:latin typeface="Segoe UI"/>
               </a:rPr>
-              <a:t>6 functional + per-schema access roles, per-developer composite roles, tag-based ARR/amount masking — Terraform, config-driven.</a:t>
+              <a:t>6 Functional + per-schema access roles, per-developer composite roles, tag-based ARR/amount masking, Terraform, config-driven.</a:t>
             </a:r>
           </a:p>
           <a:p>
@@ -8527,7 +8527,7 @@
                 </a:solidFill>
                 <a:latin typeface="Segoe UI"/>
               </a:rPr>
-              <a:t>ingest_page_views.py — ADLS → RAW with validate / quarantine / load-log / idempotency / backfill (the intentional null user_id is quarantined).</a:t>
+              <a:t>ingest_page_views.py, ADLS → RAW with validate / quarantine / load-log / idempotency / backfill (the intentional null user_id is quarantined).</a:t>
             </a:r>
           </a:p>
           <a:p>
@@ -8564,7 +8564,7 @@
                 </a:solidFill>
                 <a:latin typeface="Segoe UI"/>
               </a:rPr>
-              <a:t>incremental+deduped staging → RevOps pipeline mart; tests, clean_string macro, mesh public model — native dbt on Snowflake.</a:t>
+              <a:t>Incremental+deduped staging → RevOps pipeline mart; tests, clean_string macro, mesh public model, native dbt on Snowflake.</a:t>
             </a:r>
           </a:p>
           <a:p>
@@ -8601,7 +8601,7 @@
                 </a:solidFill>
                 <a:latin typeface="Segoe UI"/>
               </a:rPr>
-              <a:t>infra (Terraform, remote state) and dbt both deploy through GitHub Actions to DEV &amp; PROD — nothing applied by hand.</a:t>
+              <a:t>Infra (Terraform, remote state) and dbt both deploy through GitHub Actions to DEV &amp; PROD, nothing applied by hand.</a:t>
             </a:r>
           </a:p>
           <a:p>
@@ -8638,7 +8638,7 @@
                 </a:solidFill>
                 <a:latin typeface="Segoe UI"/>
               </a:rPr>
-              <a:t>OG_DEV_DB (dev sandboxes + preprod) and OG_PROD_DB — both seeded, governed, and built end-to-end.</a:t>
+              <a:t>OG_DEV_DB (dev sandboxes + preprod) and OG_PROD_DB, both seeded, governed, and built end-to-end.</a:t>
             </a:r>
           </a:p>
         </p:txBody>
@@ -8769,7 +8769,7 @@
                 </a:solidFill>
                 <a:latin typeface="Segoe UI"/>
               </a:rPr>
-              <a:t>Everything in Part 1's architecture is running in the demo account — provisioned and promoted entirely through code.</a:t>
+              <a:t>Everything in Part 1's architecture is running in the demo account, provisioned and promoted entirely through code.</a:t>
             </a:r>
           </a:p>
         </p:txBody>
@@ -8803,7 +8803,7 @@
                 </a:solidFill>
                 <a:latin typeface="Segoe UI"/>
               </a:rPr>
-              <a:t>OpenGov Data Platform  ·  Case Study — Viewpoint  ·  Akash Pahilwan</a:t>
+              <a:t>OpenGov Data Platform  ·  Case Study  ·  Akash Pahilwan</a:t>
             </a:r>
           </a:p>
         </p:txBody>
@@ -9002,7 +9002,7 @@
                 </a:solidFill>
                 <a:latin typeface="Segoe UI"/>
               </a:rPr>
-              <a:t>RBAC as built — who can touch each layer</a:t>
+              <a:t>RBAC as built, who can touch each layer</a:t>
             </a:r>
           </a:p>
         </p:txBody>
@@ -9467,7 +9467,7 @@
                 </a:solidFill>
                 <a:latin typeface="Segoe UI"/>
               </a:rPr>
-              <a:t>REVOPS_INGESTION_ADLS  (DML only — contract is deployer-owned)</a:t>
+              <a:t>REVOPS_INGESTION_ADLS  (DML only, contract is deployer-owned)</a:t>
             </a:r>
           </a:p>
         </p:txBody>
@@ -10057,7 +10057,7 @@
                 </a:solidFill>
                 <a:latin typeface="Segoe UI"/>
               </a:rPr>
-              <a:t>Access roles hold object grants; functional roles compose them; humans hold a composite/functional role — writes to shared+PROD happen only via the dbt CI service role.</a:t>
+              <a:t>Access roles hold object grants; functional roles compose them; humans hold a composite/functional role, writes to shared+PROD happen only via the dbt CI service role.</a:t>
             </a:r>
           </a:p>
         </p:txBody>
@@ -10091,7 +10091,7 @@
                 </a:solidFill>
                 <a:latin typeface="Segoe UI"/>
               </a:rPr>
-              <a:t>OpenGov Data Platform  ·  Case Study — Viewpoint  ·  Akash Pahilwan</a:t>
+              <a:t>OpenGov Data Platform  ·  Case Study  ·  Akash Pahilwan</a:t>
             </a:r>
           </a:p>
         </p:txBody>
@@ -10290,7 +10290,7 @@
                 </a:solidFill>
                 <a:latin typeface="Segoe UI"/>
               </a:rPr>
-              <a:t>ARR / amount masking — who sees what</a:t>
+              <a:t>ARR / amount masking, who sees what</a:t>
             </a:r>
           </a:p>
         </p:txBody>
@@ -10411,7 +10411,7 @@
                 </a:solidFill>
                 <a:latin typeface="Segoe UI"/>
               </a:rPr>
-              <a:t>REVOPS_ADMIN, REVOPS_DEVELOPER, REVOPS_ANALYST — NOT REVOPS_READER.</a:t>
+              <a:t>REVOPS_ADMIN, REVOPS_DEVELOPER, REVOPS_ANALYST, NOT REVOPS_READER.</a:t>
             </a:r>
           </a:p>
           <a:p>
@@ -10458,7 +10458,7 @@
                 </a:solidFill>
                 <a:latin typeface="Segoe UI"/>
               </a:rPr>
-              <a:t>        –  </a:t>
+              <a:t>        ·  </a:t>
             </a:r>
             <a:r>
               <a:rPr b="1" sz="1350">
@@ -10476,7 +10476,7 @@
                 </a:solidFill>
                 <a:latin typeface="Segoe UI"/>
               </a:rPr>
-              <a:t>— sees amount in the MART (exempt); financials are the point of their job.</a:t>
+              <a:t>Sees amount in the MART (exempt); financials are the point of their job.</a:t>
             </a:r>
           </a:p>
           <a:p>
@@ -10495,7 +10495,7 @@
                 </a:solidFill>
                 <a:latin typeface="Segoe UI"/>
               </a:rPr>
-              <a:t>        –  </a:t>
+              <a:t>        ·  </a:t>
             </a:r>
             <a:r>
               <a:rPr b="1" sz="1350">
@@ -10513,7 +10513,7 @@
                 </a:solidFill>
                 <a:latin typeface="Segoe UI"/>
               </a:rPr>
-              <a:t>— sees NULL in RAW/STAGING (readers aren't exempt).</a:t>
+              <a:t>Sees NULL in RAW/STAGING (readers aren't exempt).</a:t>
             </a:r>
           </a:p>
           <a:p>
@@ -10550,7 +10550,7 @@
                 </a:solidFill>
                 <a:latin typeface="Segoe UI"/>
               </a:rPr>
-              <a:t>the tag→policy binding is not a Terraform resource — every apply drops it, so apply_pii_tags.py re-binds it right after apply (automated in CI).</a:t>
+              <a:t>The tag→policy binding is not a Terraform resource, every apply drops it, so apply_pii_tags.py re-binds it right after apply (automated in CI).</a:t>
             </a:r>
           </a:p>
         </p:txBody>
@@ -10681,7 +10681,7 @@
                 </a:solidFill>
                 <a:latin typeface="Segoe UI"/>
               </a:rPr>
-              <a:t>Classify a column, not a table — masking scales to every domain through tags, and CI re-establishes the binding on every deploy.</a:t>
+              <a:t>Classify a column, not a table, masking scales to every domain through tags, and CI re-establishes the binding on every deploy.</a:t>
             </a:r>
           </a:p>
         </p:txBody>
@@ -10715,7 +10715,7 @@
                 </a:solidFill>
                 <a:latin typeface="Segoe UI"/>
               </a:rPr>
-              <a:t>OpenGov Data Platform  ·  Case Study — Viewpoint  ·  Akash Pahilwan</a:t>
+              <a:t>OpenGov Data Platform  ·  Case Study  ·  Akash Pahilwan</a:t>
             </a:r>
           </a:p>
         </p:txBody>
@@ -10914,7 +10914,7 @@
                 </a:solidFill>
                 <a:latin typeface="Segoe UI"/>
               </a:rPr>
-              <a:t>Telemetry ingestion — ADLS → RAW, built to the brief</a:t>
+              <a:t>Telemetry ingestion, ADLS → RAW, built to the brief</a:t>
             </a:r>
           </a:p>
         </p:txBody>
@@ -10998,7 +10998,7 @@
                 </a:solidFill>
                 <a:latin typeface="Segoe UI"/>
               </a:rPr>
-              <a:t>hourly JSON in ADLS (og-telemetry/&lt;env&gt;/product_events/page_views/dt=/hr=/) — read via a keyless external stage (storage integration, no secrets).</a:t>
+              <a:t>Hourly JSON in ADLS (og-telemetry/&lt;env&gt;/product_events/page_views/dt=/hr=/), read via a keyless external stage (storage integration, no secrets).</a:t>
             </a:r>
           </a:p>
           <a:p>
@@ -11035,7 +11035,7 @@
                 </a:solidFill>
                 <a:latin typeface="Segoe UI"/>
               </a:rPr>
-              <a:t>rows missing event_id / account_id / event_timestamp → PAGE_VIEWS_QUARANTINE; the good rows land in append-only RAW.</a:t>
+              <a:t>Rows missing event_id / account_id / event_timestamp → PAGE_VIEWS_QUARANTINE; the good rows land in append-only RAW.</a:t>
             </a:r>
           </a:p>
           <a:p>
@@ -11072,7 +11072,7 @@
                 </a:solidFill>
                 <a:latin typeface="Segoe UI"/>
               </a:rPr>
-              <a:t>one PAGE_VIEWS_LOAD_LOG row per file — file, records loaded, quarantined, timestamp — an audit trail that outlives COPY history.</a:t>
+              <a:t>One PAGE_VIEWS_LOAD_LOG row per file, file, records loaded, quarantined, timestamp, an audit trail that outlives COPY history.</a:t>
             </a:r>
           </a:p>
           <a:p>
@@ -11109,7 +11109,7 @@
                 </a:solidFill>
                 <a:latin typeface="Segoe UI"/>
               </a:rPr>
-              <a:t>per-file dedup on re-run; --path/--backfill for a folder or the full set; event_id dedup deferred to dbt staging.</a:t>
+              <a:t>Per-file dedup on re-run; --path/--backfill for a folder or the full set; event_id dedup deferred to dbt staging.</a:t>
             </a:r>
           </a:p>
           <a:p>
@@ -11277,7 +11277,7 @@
                 </a:solidFill>
                 <a:latin typeface="Segoe UI"/>
               </a:rPr>
-              <a:t>RAW is immutable truth: validate at the door, quarantine the bad, log every load — and make re-runs safe.</a:t>
+              <a:t>RAW is immutable truth: validate at the door, quarantine the bad, log every load, and make re-runs safe.</a:t>
             </a:r>
           </a:p>
         </p:txBody>
@@ -11311,7 +11311,7 @@
                 </a:solidFill>
                 <a:latin typeface="Segoe UI"/>
               </a:rPr>
-              <a:t>OpenGov Data Platform  ·  Case Study — Viewpoint  ·  Akash Pahilwan</a:t>
+              <a:t>OpenGov Data Platform  ·  Case Study  ·  Akash Pahilwan</a:t>
             </a:r>
           </a:p>
         </p:txBody>
@@ -11510,7 +11510,7 @@
                 </a:solidFill>
                 <a:latin typeface="Segoe UI"/>
               </a:rPr>
-              <a:t>dbt — staging → RevOps mart, native on Snowflake</a:t>
+              <a:t>dbt, staging → RevOps mart, native on Snowflake</a:t>
             </a:r>
           </a:p>
         </p:txBody>
@@ -11594,7 +11594,7 @@
                 </a:solidFill>
                 <a:latin typeface="Segoe UI"/>
               </a:rPr>
-              <a:t>typed + snake_case; CDC (_fivetran_synced / _loaded_at); latest-per-PK via QUALIFY; clean_string on stage_name; soft-deletes dropped.</a:t>
+              <a:t>Typed + snake_case; CDC (_fivetran_synced / _loaded_at); latest-per-PK via QUALIFY; clean_string on stage_name; soft-deletes dropped.</a:t>
             </a:r>
           </a:p>
           <a:p>
@@ -11622,7 +11622,7 @@
                 </a:solidFill>
                 <a:latin typeface="Segoe UI"/>
               </a:rPr>
-              <a:t>Mart — mart_revops__pipeline:   </a:t>
+              <a:t>Mart, mart_revops__pipeline:   </a:t>
             </a:r>
             <a:r>
               <a:rPr sz="1650">
@@ -11631,7 +11631,7 @@
                 </a:solidFill>
                 <a:latin typeface="Segoe UI"/>
               </a:rPr>
-              <a:t>opportunities × accounts + days_to_close, pipeline_stage_bucket, weighted_amount. Public mesh model a spoke consumes.</a:t>
+              <a:t>Opportunities × accounts + days_to_close, pipeline_stage_bucket, weighted_amount. Public mesh model a spoke consumes.</a:t>
             </a:r>
           </a:p>
           <a:p>
@@ -11668,7 +11668,7 @@
                 </a:solidFill>
                 <a:latin typeface="Segoe UI"/>
               </a:rPr>
-              <a:t>not_null + unique PKs, accepted_values on stage_name, relationships opp→account, sources.yml — all green.</a:t>
+              <a:t>not_null + unique PKs, accepted_values on stage_name, relationships opp→account, sources.yml, all green.</a:t>
             </a:r>
           </a:p>
           <a:p>
@@ -11705,7 +11705,7 @@
                 </a:solidFill>
                 <a:latin typeface="Segoe UI"/>
               </a:rPr>
-              <a:t>dev → your sandbox (schema__model) · preprod → OG_DEV_DB real schemas · prod → OG_PROD_DB (alias naming).</a:t>
+              <a:t>Dev → your sandbox (schema__model) · preprod → OG_DEV_DB real schemas · prod → OG_PROD_DB (alias naming).</a:t>
             </a:r>
           </a:p>
           <a:p>
@@ -11742,7 +11742,7 @@
                 </a:solidFill>
                 <a:latin typeface="Segoe UI"/>
               </a:rPr>
-              <a:t>an apply_column_tags post-hook carries the PII_FINANCIAL tag onto built columns in preprod/prod.</a:t>
+              <a:t>An apply_column_tags post-hook carries the PII_FINANCIAL tag onto built columns in preprod/prod.</a:t>
             </a:r>
           </a:p>
         </p:txBody>
@@ -11873,7 +11873,7 @@
                 </a:solidFill>
                 <a:latin typeface="Segoe UI"/>
               </a:rPr>
-              <a:t>One project, layered + contracted — incremental where volume demands it, mesh-public where consumers depend on it.</a:t>
+              <a:t>One project, layered + contracted, incremental where volume demands it, mesh-public where consumers depend on it.</a:t>
             </a:r>
           </a:p>
         </p:txBody>
@@ -11907,7 +11907,7 @@
                 </a:solidFill>
                 <a:latin typeface="Segoe UI"/>
               </a:rPr>
-              <a:t>OpenGov Data Platform  ·  Case Study — Viewpoint  ·  Akash Pahilwan</a:t>
+              <a:t>OpenGov Data Platform  ·  Case Study  ·  Akash Pahilwan</a:t>
             </a:r>
           </a:p>
         </p:txBody>
@@ -12106,7 +12106,7 @@
                 </a:solidFill>
                 <a:latin typeface="Segoe UI"/>
               </a:rPr>
-              <a:t>CI/CD — how code becomes DEV, QA &amp; PROD</a:t>
+              <a:t>CI/CD, how code becomes DEV, QA &amp; PROD</a:t>
             </a:r>
           </a:p>
         </p:txBody>
@@ -12895,7 +12895,7 @@
                 </a:solidFill>
                 <a:latin typeface="Segoe UI"/>
               </a:rPr>
-              <a:t>per-developer sandboxes in OG_DEV_DB — build &amp; iterate freely</a:t>
+              <a:t>per-developer sandboxes in OG_DEV_DB; build and iterate freely</a:t>
             </a:r>
           </a:p>
           <a:p>
@@ -12920,7 +12920,7 @@
                 </a:solidFill>
                 <a:latin typeface="Segoe UI"/>
               </a:rPr>
-              <a:t>real STAGING/MARTS in OG_DEV_DB — integration build on merge to dev</a:t>
+              <a:t>real STAGING/MARTS in OG_DEV_DB; integration build on merge to dev</a:t>
             </a:r>
           </a:p>
           <a:p>
@@ -12945,7 +12945,7 @@
                 </a:solidFill>
                 <a:latin typeface="Segoe UI"/>
               </a:rPr>
-              <a:t>OG_PROD_DB — build on merge to main; protected environment + approval</a:t>
+              <a:t>OG_PROD_DB; built on merge to main, protected environment + approval</a:t>
             </a:r>
           </a:p>
         </p:txBody>
@@ -12979,7 +12979,7 @@
                 </a:solidFill>
                 <a:latin typeface="Segoe UI"/>
               </a:rPr>
-              <a:t>OpenGov Data Platform  ·  Case Study — Viewpoint  ·  Akash Pahilwan</a:t>
+              <a:t>OpenGov Data Platform  ·  Case Study  ·  Akash Pahilwan</a:t>
             </a:r>
           </a:p>
         </p:txBody>
@@ -13178,7 +13178,7 @@
                 </a:solidFill>
                 <a:latin typeface="Segoe UI"/>
               </a:rPr>
-              <a:t>The platform is a product — I build the factory</a:t>
+              <a:t>The platform is a product, I build the factory</a:t>
             </a:r>
           </a:p>
         </p:txBody>
@@ -13262,7 +13262,7 @@
                 </a:solidFill>
                 <a:latin typeface="Segoe UI"/>
               </a:rPr>
-              <a:t>one governed foundation powering analytics and AI across GTM, Finance, Product, and HR/People.</a:t>
+              <a:t>One governed foundation powering analytics and AI across GTM, Finance, Product, and HR/People.</a:t>
             </a:r>
           </a:p>
           <a:p>
@@ -13299,7 +13299,7 @@
                 </a:solidFill>
                 <a:latin typeface="Segoe UI"/>
               </a:rPr>
-              <a:t>domain teams build on a paved path with guardrails — self-service, not a ticket queue.</a:t>
+              <a:t>Domain teams build on a paved path with guardrails, self-service, not a ticket queue.</a:t>
             </a:r>
           </a:p>
           <a:p>
@@ -13346,7 +13346,7 @@
                 </a:solidFill>
                 <a:latin typeface="Segoe UI"/>
               </a:rPr>
-              <a:t>        –  </a:t>
+              <a:t>        ·  </a:t>
             </a:r>
             <a:r>
               <a:rPr b="1" sz="1600">
@@ -13364,7 +13364,7 @@
                 </a:solidFill>
                 <a:latin typeface="Segoe UI"/>
               </a:rPr>
-              <a:t>— RBAC, masking, and lineage are built in, not bolted on.</a:t>
+              <a:t>RBAC, masking, and lineage are built in, not bolted on.</a:t>
             </a:r>
           </a:p>
           <a:p>
@@ -13383,7 +13383,7 @@
                 </a:solidFill>
                 <a:latin typeface="Segoe UI"/>
               </a:rPr>
-              <a:t>        –  </a:t>
+              <a:t>        ·  </a:t>
             </a:r>
             <a:r>
               <a:rPr b="1" sz="1600">
@@ -13401,7 +13401,7 @@
                 </a:solidFill>
                 <a:latin typeface="Segoe UI"/>
               </a:rPr>
-              <a:t>— golden templates + IaC modules; onboard a domain in a PR.</a:t>
+              <a:t>Golden templates + IaC modules; onboard a domain in a PR.</a:t>
             </a:r>
           </a:p>
           <a:p>
@@ -13420,7 +13420,7 @@
                 </a:solidFill>
                 <a:latin typeface="Segoe UI"/>
               </a:rPr>
-              <a:t>        –  </a:t>
+              <a:t>        ·  </a:t>
             </a:r>
             <a:r>
               <a:rPr b="1" sz="1600">
@@ -13438,7 +13438,7 @@
                 </a:solidFill>
                 <a:latin typeface="Segoe UI"/>
               </a:rPr>
-              <a:t>— freshness, quality, and cost measured from day one.</a:t>
+              <a:t>Freshness, quality, and cost measured from day one.</a:t>
             </a:r>
           </a:p>
           <a:p>
@@ -13457,7 +13457,7 @@
                 </a:solidFill>
                 <a:latin typeface="Segoe UI"/>
               </a:rPr>
-              <a:t>        –  </a:t>
+              <a:t>        ·  </a:t>
             </a:r>
             <a:r>
               <a:rPr b="1" sz="1600">
@@ -13475,7 +13475,7 @@
                 </a:solidFill>
                 <a:latin typeface="Segoe UI"/>
               </a:rPr>
-              <a:t>— everything is code, tested in CI, rebuildable in any environment.</a:t>
+              <a:t>Everything is code, tested in CI, rebuildable in any environment.</a:t>
             </a:r>
           </a:p>
         </p:txBody>
@@ -13606,7 +13606,7 @@
                 </a:solidFill>
                 <a:latin typeface="Segoe UI"/>
               </a:rPr>
-              <a:t>Trust and speed are not a trade-off — the right guardrails deliver both.</a:t>
+              <a:t>Trust and speed are not a trade-off, the right guardrails deliver both.</a:t>
             </a:r>
           </a:p>
         </p:txBody>
@@ -13640,7 +13640,7 @@
                 </a:solidFill>
                 <a:latin typeface="Segoe UI"/>
               </a:rPr>
-              <a:t>OpenGov Data Platform  ·  Case Study — Viewpoint  ·  Akash Pahilwan</a:t>
+              <a:t>OpenGov Data Platform  ·  Case Study  ·  Akash Pahilwan</a:t>
             </a:r>
           </a:p>
         </p:txBody>
@@ -13960,7 +13960,7 @@
                 </a:solidFill>
                 <a:latin typeface="Segoe UI"/>
               </a:rPr>
-              <a:t>it's their default role and secondary roles are OFF — every session is exactly one role, so masking checks are unambiguous.</a:t>
+              <a:t>It's their default role and secondary roles are OFF, every session is exactly one role, so masking checks are unambiguous.</a:t>
             </a:r>
           </a:p>
           <a:p>
@@ -13997,7 +13997,7 @@
                 </a:solidFill>
                 <a:latin typeface="Segoe UI"/>
               </a:rPr>
-              <a:t>separate sandboxes, &lt;schema&gt;__&lt;model&gt; naming; can't touch shared STAGING/MARTS or anything in PROD.</a:t>
+              <a:t>Separate sandboxes, &lt;schema&gt;__&lt;model&gt; naming; can't touch shared STAGING/MARTS or anything in PROD.</a:t>
             </a:r>
           </a:p>
           <a:p>
@@ -14071,7 +14071,7 @@
                 </a:solidFill>
                 <a:latin typeface="Segoe UI"/>
               </a:rPr>
-              <a:t>add to environments.csv developers + human_users.csv → composite role + sandbox generated by Terraform in a PR.</a:t>
+              <a:t>Add to environments.csv developers + human_users.csv → composite role + sandbox generated by Terraform in a PR.</a:t>
             </a:r>
           </a:p>
         </p:txBody>
@@ -14236,7 +14236,7 @@
                 </a:solidFill>
                 <a:latin typeface="Segoe UI"/>
               </a:rPr>
-              <a:t>OpenGov Data Platform  ·  Case Study — Viewpoint  ·  Akash Pahilwan</a:t>
+              <a:t>OpenGov Data Platform  ·  Case Study  ·  Akash Pahilwan</a:t>
             </a:r>
           </a:p>
         </p:txBody>
@@ -14519,7 +14519,7 @@
                 </a:solidFill>
                 <a:latin typeface="Segoe UI"/>
               </a:rPr>
-              <a:t>one IaC-first, governed platform — and it's running, not just drawn.</a:t>
+              <a:t>One IaC-first, governed platform, and it's running, not just drawn.</a:t>
             </a:r>
           </a:p>
           <a:p>
@@ -14593,7 +14593,7 @@
                 </a:solidFill>
                 <a:latin typeface="Segoe UI"/>
               </a:rPr>
-              <a:t>config-driven RBAC + tag masking, per-developer sandboxes, CI/CD to DEV &amp; PROD.</a:t>
+              <a:t>Config-driven RBAC + tag masking, per-developer sandboxes, CI/CD to DEV &amp; PROD.</a:t>
             </a:r>
           </a:p>
           <a:p>
@@ -14630,7 +14630,7 @@
                 </a:solidFill>
                 <a:latin typeface="Segoe UI"/>
               </a:rPr>
-              <a:t>buy vs build · incremental vs full-refresh · centralized vs federated (dbt Mesh) · key-pair/OIDC secrets.</a:t>
+              <a:t>Buy vs build · incremental vs full-refresh · centralized vs federated (dbt Mesh) · key-pair/OIDC secrets.</a:t>
             </a:r>
           </a:p>
           <a:p>
@@ -14667,7 +14667,7 @@
                 </a:solidFill>
                 <a:latin typeface="Segoe UI"/>
               </a:rPr>
-              <a:t>a 10th domain is the same CSV rows + module — roles, masking, and CI all generated.</a:t>
+              <a:t>A 10th domain is the same CSV rows + module, roles, masking, and CI all generated.</a:t>
             </a:r>
           </a:p>
         </p:txBody>
@@ -14798,7 +14798,7 @@
                 </a:solidFill>
                 <a:latin typeface="Segoe UI"/>
               </a:rPr>
-              <a:t>The measure of the platform: how fast a federated team ships something trustworthy on top of it — safely, and on their own.</a:t>
+              <a:t>The measure of the platform: how fast a federated team ships something trustworthy on top of it, safely, and on their own.</a:t>
             </a:r>
           </a:p>
         </p:txBody>
@@ -14832,7 +14832,7 @@
                 </a:solidFill>
                 <a:latin typeface="Segoe UI"/>
               </a:rPr>
-              <a:t>OpenGov Data Platform  ·  Case Study — Viewpoint  ·  Akash Pahilwan</a:t>
+              <a:t>OpenGov Data Platform  ·  Case Study  ·  Akash Pahilwan</a:t>
             </a:r>
           </a:p>
         </p:txBody>
@@ -15011,7 +15011,7 @@
                 </a:solidFill>
                 <a:latin typeface="Segoe UI"/>
               </a:rPr>
-              <a:t>Deep dives for the panel's probes — pull these up on demand.</a:t>
+              <a:t>Deep dives for the panel's probes. Pull these up on demand.</a:t>
             </a:r>
           </a:p>
         </p:txBody>
@@ -15175,7 +15175,7 @@
                 </a:solidFill>
                 <a:latin typeface="Segoe UI"/>
               </a:rPr>
-              <a:t>Scaling RBAC to 10 domains — least privilege by construction</a:t>
+              <a:t>Scaling RBAC to 10 domains, least privilege by construction</a:t>
             </a:r>
           </a:p>
         </p:txBody>
@@ -15296,7 +15296,7 @@
                 </a:solidFill>
                 <a:latin typeface="Segoe UI"/>
               </a:rPr>
-              <a:t>REVOPS_ANALYST reads MARTS_* (all marts); FINANCE_ANALYST reads MARTS_FINANCE ONLY — an exact-schema grant, not the wildcard.</a:t>
+              <a:t>REVOPS_ANALYST reads MARTS_* (all marts); FINANCE_ANALYST reads MARTS_FINANCE ONLY, an exact-schema grant, not the wildcard.</a:t>
             </a:r>
           </a:p>
           <a:p>
@@ -15370,7 +15370,7 @@
                 </a:solidFill>
                 <a:latin typeface="Segoe UI"/>
               </a:rPr>
-              <a:t>REVOPS_DEVELOPER (write, incl PROD) is service-only — sync_config.py rejects granting it to a human; humans get read + their own sandbox.</a:t>
+              <a:t>REVOPS_DEVELOPER (write, incl PROD) is service-only, sync_config.py rejects granting it to a human; humans get read + their own sandbox.</a:t>
             </a:r>
           </a:p>
           <a:p>
@@ -15538,7 +15538,7 @@
                 </a:solidFill>
                 <a:latin typeface="Segoe UI"/>
               </a:rPr>
-              <a:t>Least privilege scales because it's generated from config — each domain analyst is confined to that domain's marts by an exact grant.</a:t>
+              <a:t>Least privilege scales because it's generated from config, each domain analyst is confined to that domain's marts by an exact grant.</a:t>
             </a:r>
           </a:p>
         </p:txBody>
@@ -15572,7 +15572,7 @@
                 </a:solidFill>
                 <a:latin typeface="Segoe UI"/>
               </a:rPr>
-              <a:t>OpenGov Data Platform  ·  Case Study — Viewpoint  ·  Akash Pahilwan</a:t>
+              <a:t>OpenGov Data Platform  ·  Case Study  ·  Akash Pahilwan</a:t>
             </a:r>
           </a:p>
         </p:txBody>
@@ -15771,7 +15771,7 @@
                 </a:solidFill>
                 <a:latin typeface="Segoe UI"/>
               </a:rPr>
-              <a:t>Incremental vs full-refresh — and fixing incrementals</a:t>
+              <a:t>Incremental vs full-refresh, and fixing incrementals</a:t>
             </a:r>
           </a:p>
         </p:txBody>
@@ -15855,7 +15855,7 @@
                 </a:solidFill>
                 <a:latin typeface="Segoe UI"/>
               </a:rPr>
-              <a:t>high-volume/append sources (telemetry, CDC tables) — build only rows since the last watermark; cheap, fast.</a:t>
+              <a:t>High-volume/append sources (telemetry, CDC tables), build only rows since the last watermark; cheap, fast.</a:t>
             </a:r>
           </a:p>
           <a:p>
@@ -15892,7 +15892,7 @@
                 </a:solidFill>
                 <a:latin typeface="Segoe UI"/>
               </a:rPr>
-              <a:t>small dimensions, or after a logic change — rebuild from scratch.</a:t>
+              <a:t>Small dimensions, or after a logic change, rebuild from scratch.</a:t>
             </a:r>
           </a:p>
           <a:p>
@@ -15929,7 +15929,7 @@
                 </a:solidFill>
                 <a:latin typeface="Segoe UI"/>
               </a:rPr>
-              <a:t>a normal build only merges NEW rows, so a logic fix to an incremental model never re-cleans already-materialized rows.</a:t>
+              <a:t>A normal build only merges NEW rows, so a logic fix to an incremental model never re-cleans already-materialized rows.</a:t>
             </a:r>
           </a:p>
           <a:p>
@@ -15966,7 +15966,7 @@
                 </a:solidFill>
                 <a:latin typeface="Segoe UI"/>
               </a:rPr>
-              <a:t>a manual full-refresh workflow — branch (dev→preprod / main→prod) × scope (all | only models changed in the last commit).</a:t>
+              <a:t>A manual full-refresh workflow, branch (dev→preprod / main→prod) × scope (all | only models changed in the last commit).</a:t>
             </a:r>
           </a:p>
           <a:p>
@@ -16003,7 +16003,7 @@
                 </a:solidFill>
                 <a:latin typeface="Segoe UI"/>
               </a:rPr>
-              <a:t>the page_views user_id VARIANT-null fix needed a full-refresh to purge 2 historical bad rows from PROD.</a:t>
+              <a:t>The page_views user_id VARIANT-null fix needed a full-refresh to purge 2 historical bad rows from PROD.</a:t>
             </a:r>
           </a:p>
         </p:txBody>
@@ -16134,7 +16134,7 @@
                 </a:solidFill>
                 <a:latin typeface="Segoe UI"/>
               </a:rPr>
-              <a:t>Pick incremental for volume, full-refresh for correctness — and make the full-refresh a one-click, scoped workflow.</a:t>
+              <a:t>Pick incremental for volume, full-refresh for correctness, and make the full-refresh a one-click, scoped workflow.</a:t>
             </a:r>
           </a:p>
         </p:txBody>
@@ -16168,7 +16168,7 @@
                 </a:solidFill>
                 <a:latin typeface="Segoe UI"/>
               </a:rPr>
-              <a:t>OpenGov Data Platform  ·  Case Study — Viewpoint  ·  Akash Pahilwan</a:t>
+              <a:t>OpenGov Data Platform  ·  Case Study  ·  Akash Pahilwan</a:t>
             </a:r>
           </a:p>
         </p:txBody>
@@ -16451,7 +16451,7 @@
                 </a:solidFill>
                 <a:latin typeface="Segoe UI"/>
               </a:rPr>
-              <a:t>key-pair (JWT) for Snowflake, storage key for the TF backend — all GitHub secrets; the private key touches only a temp file in the job.</a:t>
+              <a:t>Key-pair (JWT) for Snowflake, storage key for the TF backend, all GitHub secrets; the private key touches only a temp file in the job.</a:t>
             </a:r>
           </a:p>
           <a:p>
@@ -16488,7 +16488,7 @@
                 </a:solidFill>
                 <a:latin typeface="Segoe UI"/>
               </a:rPr>
-              <a:t>secrets are exposed only to post-merge apply jobs; PR-triggered plan never sees them; PROD gated by a protected Environment + approval.</a:t>
+              <a:t>Secrets are exposed only to post-merge apply jobs; PR-triggered plan never sees them; PROD gated by a protected Environment + approval.</a:t>
             </a:r>
           </a:p>
           <a:p>
@@ -16525,7 +16525,7 @@
                 </a:solidFill>
                 <a:latin typeface="Segoe UI"/>
               </a:rPr>
-              <a:t>Terraform state in an azurerm backend (ADLS), so CI and local share one source of truth — no drift, no local state to lose.</a:t>
+              <a:t>Terraform state in an azurerm backend (ADLS), so CI and local share one source of truth, no drift, no local state to lose.</a:t>
             </a:r>
           </a:p>
           <a:p>
@@ -16599,7 +16599,7 @@
                 </a:solidFill>
                 <a:latin typeface="Segoe UI"/>
               </a:rPr>
-              <a:t>sync_config.py validates every reference (unknown role/schema/env) and rejects a service-only role reaching a human — the linter is the reviewer.</a:t>
+              <a:t>sync_config.py validates every reference (unknown role/schema/env) and rejects a service-only role reaching a human, the linter is the reviewer.</a:t>
             </a:r>
           </a:p>
         </p:txBody>
@@ -16730,7 +16730,7 @@
                 </a:solidFill>
                 <a:latin typeface="Segoe UI"/>
               </a:rPr>
-              <a:t>The pipeline is the control plane: reviewed, idempotent, secret-safe, and standards-enforcing — provisioning you can trust.</a:t>
+              <a:t>The pipeline is the control plane: reviewed, idempotent, secret-safe, and standards-enforcing, provisioning you can trust.</a:t>
             </a:r>
           </a:p>
         </p:txBody>
@@ -16764,7 +16764,7 @@
                 </a:solidFill>
                 <a:latin typeface="Segoe UI"/>
               </a:rPr>
-              <a:t>OpenGov Data Platform  ·  Case Study — Viewpoint  ·  Akash Pahilwan</a:t>
+              <a:t>OpenGov Data Platform  ·  Case Study  ·  Akash Pahilwan</a:t>
             </a:r>
           </a:p>
         </p:txBody>
@@ -17047,7 +17047,7 @@
                 </a:solidFill>
                 <a:latin typeface="Segoe UI"/>
               </a:rPr>
-              <a:t>each micro-partition shreds consistent JSON paths into typed, compressed sub-columns with min/max stats — native-column treatment.</a:t>
+              <a:t>Each micro-partition shreds consistent JSON paths into typed, compressed sub-columns with min/max stats, native-column treatment.</a:t>
             </a:r>
           </a:p>
           <a:p>
@@ -17084,7 +17084,7 @@
                 </a:solidFill>
                 <a:latin typeface="Segoe UI"/>
               </a:rPr>
-              <a:t>selecting payload:properties.duration_ms reads only that sub-column off disk — never the whole document.</a:t>
+              <a:t>Selecting payload:properties.duration_ms reads only that sub-column off disk, never the whole document.</a:t>
             </a:r>
           </a:p>
           <a:p>
@@ -17121,7 +17121,7 @@
                 </a:solidFill>
                 <a:latin typeface="Segoe UI"/>
               </a:rPr>
-              <a:t>filters on extracted paths skip whole micro-partitions via metadata — scan cost tracks the answer, not the table.</a:t>
+              <a:t>Filters on extracted paths skip whole micro-partitions via metadata, scan cost tracks the answer, not the table.</a:t>
             </a:r>
           </a:p>
           <a:p>
@@ -17158,7 +17158,7 @@
                 </a:solidFill>
                 <a:latin typeface="Segoe UI"/>
               </a:rPr>
-              <a:t>wildly heterogeneous keys defeat sub-columnarization — promote hot filter / dedup keys to real columns (event_id).</a:t>
+              <a:t>Wildly heterogeneous keys defeat sub-columnarization, promote hot filter / dedup keys to real columns (event_id).</a:t>
             </a:r>
           </a:p>
           <a:p>
@@ -17278,7 +17278,7 @@
                 </a:solidFill>
                 <a:latin typeface="Consolas"/>
               </a:rPr>
-              <a:t>VARIANT internals — sketch</a:t>
+              <a:t>VARIANT internals (sketch)</a:t>
             </a:r>
           </a:p>
           <a:p>
@@ -17733,7 +17733,7 @@
                 </a:solidFill>
                 <a:latin typeface="Segoe UI"/>
               </a:rPr>
-              <a:t>Schema-on-read is nearly free at query time — consistent paths are columnarized on write; type once in staging, downstream never parses JSON.</a:t>
+              <a:t>Schema-on-read is nearly free at query time, consistent paths are columnarized on write; type once in staging, downstream never parses JSON.</a:t>
             </a:r>
           </a:p>
         </p:txBody>
@@ -17767,7 +17767,7 @@
                 </a:solidFill>
                 <a:latin typeface="Segoe UI"/>
               </a:rPr>
-              <a:t>OpenGov Data Platform  ·  Case Study — Viewpoint  ·  Akash Pahilwan</a:t>
+              <a:t>OpenGov Data Platform  ·  Case Study  ·  Akash Pahilwan</a:t>
             </a:r>
           </a:p>
         </p:txBody>
@@ -17966,7 +17966,7 @@
                 </a:solidFill>
                 <a:latin typeface="Segoe UI"/>
               </a:rPr>
-              <a:t>ADLS layout &amp; hourly loads — append-only RAW</a:t>
+              <a:t>ADLS layout &amp; hourly loads, append-only RAW</a:t>
             </a:r>
           </a:p>
         </p:txBody>
@@ -18050,7 +18050,7 @@
                 </a:solidFill>
                 <a:latin typeface="Segoe UI"/>
               </a:rPr>
-              <a:t>source/object/dt=YYYY-MM-DD/hr=HH/ — hourly runs list one narrow prefix; backfill = re-point at a date range; lifecycle rules attach per prefix.</a:t>
+              <a:t>Source/object/dt=YYYY-MM-DD/hr=HH/, hourly runs list one narrow prefix; backfill = re-point at a date range; lifecycle rules attach per prefix.</a:t>
             </a:r>
           </a:p>
           <a:p>
@@ -18087,7 +18087,7 @@
                 </a:solidFill>
                 <a:latin typeface="Segoe UI"/>
               </a:rPr>
-              <a:t>RAW is an immutable log, not a mirror — 'latest' applies to which files we read this run, not to what we keep.</a:t>
+              <a:t>RAW is an immutable log, not a mirror, 'latest' applies to which files we read this run, not to what we keep.</a:t>
             </a:r>
           </a:p>
           <a:p>
@@ -18161,7 +18161,7 @@
                 </a:solidFill>
                 <a:latin typeface="Segoe UI"/>
               </a:rPr>
-              <a:t>COPY FORCE=TRUE into a fresh table, then ALTER TABLE SWAP — rebuild history, never edit it.</a:t>
+              <a:t>COPY FORCE=TRUE into a fresh table, then ALTER TABLE SWAP, rebuild history, never edit it.</a:t>
             </a:r>
           </a:p>
           <a:p>
@@ -18198,7 +18198,7 @@
                 </a:solidFill>
                 <a:latin typeface="Segoe UI"/>
               </a:rPr>
-              <a:t>scheduled Python + COPY keeps validation / quarantine / _LOAD_LOG in code; production evolution: Snowpipe auto-ingest per S3 event, no scheduler.</a:t>
+              <a:t>Scheduled Python + COPY keeps validation / quarantine / _LOAD_LOG in code; production evolution: Snowpipe auto-ingest per S3 event, no scheduler.</a:t>
             </a:r>
           </a:p>
         </p:txBody>
@@ -18698,7 +18698,7 @@
                 </a:solidFill>
                 <a:latin typeface="Segoe UI"/>
               </a:rPr>
-              <a:t>Copy only the latest files, keep every row — append-only RAW plus three idempotency layers makes any re-run or backfill safe.</a:t>
+              <a:t>Copy only the latest files, keep every row, append-only RAW plus three idempotency layers makes any re-run or backfill safe.</a:t>
             </a:r>
           </a:p>
         </p:txBody>
@@ -18732,7 +18732,7 @@
                 </a:solidFill>
                 <a:latin typeface="Segoe UI"/>
               </a:rPr>
-              <a:t>OpenGov Data Platform  ·  Case Study — Viewpoint  ·  Akash Pahilwan</a:t>
+              <a:t>OpenGov Data Platform  ·  Case Study  ·  Akash Pahilwan</a:t>
             </a:r>
           </a:p>
         </p:txBody>
@@ -18931,7 +18931,7 @@
                 </a:solidFill>
                 <a:latin typeface="Segoe UI"/>
               </a:rPr>
-              <a:t>COPY INTO — load logs &amp; the 64-day horizon</a:t>
+              <a:t>COPY INTO, load logs &amp; the 64-day horizon</a:t>
             </a:r>
           </a:p>
         </p:txBody>
@@ -19015,7 +19015,7 @@
                 </a:solidFill>
                 <a:latin typeface="Segoe UI"/>
               </a:rPr>
-              <a:t>rows_parsed / rows_loaded / errors per file — the Python job persists it to _LOAD_LOG; ours never expires.</a:t>
+              <a:t>rows_parsed / rows_loaded / errors per file, the Python job persists it to _LOAD_LOG; ours never expires.</a:t>
             </a:r>
           </a:p>
           <a:p>
@@ -19089,7 +19089,7 @@
                 </a:solidFill>
                 <a:latin typeface="Segoe UI"/>
               </a:rPr>
-              <a:t>the internal metadata COPY uses to skip already-loaded files expires after 64 days — separate from the audit views.</a:t>
+              <a:t>The internal metadata COPY uses to skip already-loaded files expires after 64 days, separate from the audit views.</a:t>
             </a:r>
           </a:p>
           <a:p>
@@ -19126,7 +19126,7 @@
                 </a:solidFill>
                 <a:latin typeface="Segoe UI"/>
               </a:rPr>
-              <a:t>unknown-status files are skipped — a silent gap, not duplicates; backfill via LOAD_UNCERTAIN_FILES=TRUE or FORCE + SWAP.</a:t>
+              <a:t>Unknown-status files are skipped, a silent gap, not duplicates; backfill via LOAD_UNCERTAIN_FILES=TRUE or FORCE + SWAP.</a:t>
             </a:r>
           </a:p>
           <a:p>
@@ -19749,7 +19749,7 @@
                 </a:solidFill>
                 <a:latin typeface="Segoe UI"/>
               </a:rPr>
-              <a:t>Snowflake logs every COPY (14-day / 365-day views) and returns a per-file summary — persisting it in _LOAD_LOG gives an audit trail that outlives every retention window.</a:t>
+              <a:t>Snowflake logs every COPY (14-day / 365-day views) and returns a per-file summary, persisting it in _LOAD_LOG gives an audit trail that outlives every retention window.</a:t>
             </a:r>
           </a:p>
         </p:txBody>
@@ -19783,7 +19783,7 @@
                 </a:solidFill>
                 <a:latin typeface="Segoe UI"/>
               </a:rPr>
-              <a:t>OpenGov Data Platform  ·  Case Study — Viewpoint  ·  Akash Pahilwan</a:t>
+              <a:t>OpenGov Data Platform  ·  Case Study  ·  Akash Pahilwan</a:t>
             </a:r>
           </a:p>
         </p:txBody>
@@ -20584,7 +20584,7 @@
                 </a:solidFill>
                 <a:latin typeface="Segoe UI"/>
               </a:rPr>
-              <a:t>RAW  — source-system schemas</a:t>
+              <a:t>RAW: source-system schemas</a:t>
             </a:r>
           </a:p>
         </p:txBody>
@@ -20637,7 +20637,7 @@
                 </a:solidFill>
                 <a:latin typeface="Segoe UI"/>
               </a:rPr>
-              <a:t>STAGING — cleaned / conformed</a:t>
+              <a:t>STAGING: cleaned / conformed</a:t>
             </a:r>
           </a:p>
         </p:txBody>
@@ -20690,7 +20690,7 @@
                 </a:solidFill>
                 <a:latin typeface="Segoe UI"/>
               </a:rPr>
-              <a:t>MARTS — domain, business-ready</a:t>
+              <a:t>MARTS: domain, business-ready</a:t>
             </a:r>
           </a:p>
         </p:txBody>
@@ -20743,7 +20743,7 @@
                 </a:solidFill>
                 <a:latin typeface="Segoe UI"/>
               </a:rPr>
-              <a:t>SANDBOX — analyst scratch</a:t>
+              <a:t>SANDBOX: analyst scratch</a:t>
             </a:r>
           </a:p>
         </p:txBody>
@@ -21191,7 +21191,7 @@
                 </a:solidFill>
                 <a:latin typeface="Segoe UI"/>
               </a:rPr>
-              <a:t>OpenGov Data Platform  ·  Case Study — Viewpoint  ·  Akash Pahilwan</a:t>
+              <a:t>OpenGov Data Platform  ·  Case Study  ·  Akash Pahilwan</a:t>
             </a:r>
           </a:p>
         </p:txBody>
@@ -22082,7 +22082,7 @@
                 </a:solidFill>
                 <a:latin typeface="Segoe UI"/>
               </a:rPr>
-              <a:t>OpenGov Data Platform  ·  Case Study — Viewpoint  ·  Akash Pahilwan</a:t>
+              <a:t>OpenGov Data Platform  ·  Case Study  ·  Akash Pahilwan</a:t>
             </a:r>
           </a:p>
         </p:txBody>
@@ -22365,7 +22365,7 @@
                 </a:solidFill>
                 <a:latin typeface="Segoe UI"/>
               </a:rPr>
-              <a:t>the upstream source shape is uncontrolled; our deployed objects change only through reviewed PRs.</a:t>
+              <a:t>The upstream source shape is uncontrolled; our deployed objects change only through reviewed PRs.</a:t>
             </a:r>
           </a:p>
           <a:p>
@@ -22393,7 +22393,7 @@
                 </a:solidFill>
                 <a:latin typeface="Segoe UI"/>
               </a:rPr>
-              <a:t>Custom path — schema-on-read:   </a:t>
+              <a:t>Custom path, schema-on-read:   </a:t>
             </a:r>
             <a:r>
               <a:rPr sz="1650">
@@ -22402,7 +22402,7 @@
                 </a:solidFill>
                 <a:latin typeface="Segoe UI"/>
               </a:rPr>
-              <a:t>RAW lands each record as a VARIANT; a new source field needs zero DDL, zero deploy — typed at read time in dbt.</a:t>
+              <a:t>RAW lands each record as a VARIANT; a new source field needs zero DDL, zero deploy, typed at read time in dbt.</a:t>
             </a:r>
           </a:p>
           <a:p>
@@ -22439,7 +22439,7 @@
                 </a:solidFill>
                 <a:latin typeface="Segoe UI"/>
               </a:rPr>
-              <a:t>compare the payload to a registered contract — additive → log + surface; breaking → alert + quarantine. CI/CD never mutates a live table from drift.</a:t>
+              <a:t>Compare the payload to a registered contract, additive → log + surface; breaking → alert + quarantine. CI/CD never mutates a live table from drift.</a:t>
             </a:r>
           </a:p>
           <a:p>
@@ -22476,7 +22476,7 @@
                 </a:solidFill>
                 <a:latin typeface="Segoe UI"/>
               </a:rPr>
-              <a:t>expose it by adding one typed column in dbt; CI runs contracts + tests; review + merge deploys it.</a:t>
+              <a:t>Expose it by adding one typed column in dbt; CI runs contracts + tests; review + merge deploys it.</a:t>
             </a:r>
           </a:p>
           <a:p>
@@ -22504,7 +22504,7 @@
                 </a:solidFill>
                 <a:latin typeface="Segoe UI"/>
               </a:rPr>
-              <a:t>Fivetran — schema-on-write:   </a:t>
+              <a:t>Fivetran, schema-on-write:   </a:t>
             </a:r>
             <a:r>
               <a:rPr sz="1650">
@@ -22513,7 +22513,7 @@
                 </a:solidFill>
                 <a:latin typeface="Segoe UI"/>
               </a:rPr>
-              <a:t>it types columns and ALTERs its own RAW tables on drift; the dbt source contract + tests are our CI tripwire one layer down.</a:t>
+              <a:t>It types columns and ALTERs its own RAW tables on drift; the dbt source contract + tests are our CI tripwire one layer down.</a:t>
             </a:r>
           </a:p>
         </p:txBody>
@@ -23068,7 +23068,7 @@
                 </a:solidFill>
                 <a:latin typeface="Segoe UI"/>
               </a:rPr>
-              <a:t>Upstream drift lands safely in VARIANT; the deployed schema changes only through a reviewed, tested PR — drift is a blocking CI signal, not silent breakage.</a:t>
+              <a:t>Upstream drift lands safely in VARIANT; the deployed schema changes only through a reviewed, tested PR, drift is a blocking CI signal, not silent breakage.</a:t>
             </a:r>
           </a:p>
         </p:txBody>
@@ -23102,7 +23102,7 @@
                 </a:solidFill>
                 <a:latin typeface="Segoe UI"/>
               </a:rPr>
-              <a:t>OpenGov Data Platform  ·  Case Study — Viewpoint  ·  Akash Pahilwan</a:t>
+              <a:t>OpenGov Data Platform  ·  Case Study  ·  Akash Pahilwan</a:t>
             </a:r>
           </a:p>
         </p:txBody>
@@ -23385,7 +23385,7 @@
                 </a:solidFill>
                 <a:latin typeface="Segoe UI"/>
               </a:rPr>
-              <a:t>S3 keys as source/table/ingest_date=… — immutable, append-only, replayable.</a:t>
+              <a:t>S3 keys as source/table/ingest_date=…, immutable, append-only, replayable.</a:t>
             </a:r>
           </a:p>
           <a:p>
@@ -23459,7 +23459,7 @@
                 </a:solidFill>
                 <a:latin typeface="Segoe UI"/>
               </a:rPr>
-              <a:t>external stage + COPY INTO, or Snowpipe on arrival; capture METADATA$FILENAME for lineage.</a:t>
+              <a:t>External stage + COPY INTO, or Snowpipe on arrival; capture METADATA$FILENAME for lineage.</a:t>
             </a:r>
           </a:p>
           <a:p>
@@ -23496,7 +23496,7 @@
                 </a:solidFill>
                 <a:latin typeface="Segoe UI"/>
               </a:rPr>
-              <a:t>validate required fields; bad rows → _QUARANTINE table; never fail the whole batch on one row.</a:t>
+              <a:t>Validate required fields; bad rows → _QUARANTINE table; never fail the whole batch on one row.</a:t>
             </a:r>
           </a:p>
           <a:p>
@@ -23533,7 +23533,7 @@
                 </a:solidFill>
                 <a:latin typeface="Segoe UI"/>
               </a:rPr>
-              <a:t>a _LOAD_LOG row per file — records processed, quarantined, load timestamp.</a:t>
+              <a:t>A _LOAD_LOG row per file, records processed, quarantined, load timestamp.</a:t>
             </a:r>
           </a:p>
           <a:p>
@@ -23570,7 +23570,7 @@
                 </a:solidFill>
                 <a:latin typeface="Segoe UI"/>
               </a:rPr>
-              <a:t>dedup on natural key so re-loading a file is a no-op.</a:t>
+              <a:t>Dedup on natural key so re-loading a file is a no-op.</a:t>
             </a:r>
           </a:p>
         </p:txBody>
@@ -23701,7 +23701,7 @@
                 </a:solidFill>
                 <a:latin typeface="Segoe UI"/>
               </a:rPr>
-              <a:t>RAW is immutable truth — validate and quarantine at the door, log every load.</a:t>
+              <a:t>RAW is immutable truth, validate and quarantine at the door, log every load.</a:t>
             </a:r>
           </a:p>
         </p:txBody>
@@ -23735,7 +23735,7 @@
                 </a:solidFill>
                 <a:latin typeface="Segoe UI"/>
               </a:rPr>
-              <a:t>OpenGov Data Platform  ·  Case Study — Viewpoint  ·  Akash Pahilwan</a:t>
+              <a:t>OpenGov Data Platform  ·  Case Study  ·  Akash Pahilwan</a:t>
             </a:r>
           </a:p>
         </p:txBody>
@@ -24037,7 +24037,7 @@
                 </a:solidFill>
                 <a:latin typeface="Segoe UI"/>
               </a:rPr>
-              <a:t>        –  </a:t>
+              <a:t>        ·  </a:t>
             </a:r>
             <a:r>
               <a:rPr b="1" sz="1500">
@@ -24055,7 +24055,7 @@
                 </a:solidFill>
                 <a:latin typeface="Segoe UI"/>
               </a:rPr>
-              <a:t>— loader-owned, immutable, source-system schemas, no business logic.</a:t>
+              <a:t>Loader-owned, immutable, source-system schemas, no business logic.</a:t>
             </a:r>
           </a:p>
           <a:p>
@@ -24074,7 +24074,7 @@
                 </a:solidFill>
                 <a:latin typeface="Segoe UI"/>
               </a:rPr>
-              <a:t>        –  </a:t>
+              <a:t>        ·  </a:t>
             </a:r>
             <a:r>
               <a:rPr b="1" sz="1500">
@@ -24092,7 +24092,7 @@
                 </a:solidFill>
                 <a:latin typeface="Segoe UI"/>
               </a:rPr>
-              <a:t>— dbt-owned; typed, renamed, conformed; light transforms.</a:t>
+              <a:t>dbt-owned; typed, renamed, conformed; light transforms.</a:t>
             </a:r>
           </a:p>
           <a:p>
@@ -24111,7 +24111,7 @@
                 </a:solidFill>
                 <a:latin typeface="Segoe UI"/>
               </a:rPr>
-              <a:t>        –  </a:t>
+              <a:t>        ·  </a:t>
             </a:r>
             <a:r>
               <a:rPr b="1" sz="1500">
@@ -24129,7 +24129,7 @@
                 </a:solidFill>
                 <a:latin typeface="Segoe UI"/>
               </a:rPr>
-              <a:t>— dbt-owned; business-ready, domain schemas, tested &amp; documented.</a:t>
+              <a:t>dbt-owned; business-ready, domain schemas, tested &amp; documented.</a:t>
             </a:r>
           </a:p>
           <a:p>
@@ -24148,7 +24148,7 @@
                 </a:solidFill>
                 <a:latin typeface="Segoe UI"/>
               </a:rPr>
-              <a:t>        –  </a:t>
+              <a:t>        ·  </a:t>
             </a:r>
             <a:r>
               <a:rPr b="1" sz="1500">
@@ -24166,7 +24166,7 @@
                 </a:solidFill>
                 <a:latin typeface="Segoe UI"/>
               </a:rPr>
-              <a:t>— analyst scratch; safe to break, no downstream dependencies.</a:t>
+              <a:t>Analyst scratch; safe to break, no downstream dependencies.</a:t>
             </a:r>
           </a:p>
           <a:p>
@@ -24203,7 +24203,7 @@
                 </a:solidFill>
                 <a:latin typeface="Segoe UI"/>
               </a:rPr>
-              <a:t>separate ingest / transform / BI warehouses; right-sized; auto-suspend for cost.</a:t>
+              <a:t>Separate ingest / transform / BI warehouses; right-sized; auto-suspend for cost.</a:t>
             </a:r>
           </a:p>
           <a:p>
@@ -24240,7 +24240,7 @@
                 </a:solidFill>
                 <a:latin typeface="Segoe UI"/>
               </a:rPr>
-              <a:t>dev and prod isolated; promotion through CI, never manual edits in prod.</a:t>
+              <a:t>Dev and prod isolated; promotion through CI, never manual edits in prod.</a:t>
             </a:r>
           </a:p>
         </p:txBody>
@@ -24405,7 +24405,7 @@
                 </a:solidFill>
                 <a:latin typeface="Segoe UI"/>
               </a:rPr>
-              <a:t>OpenGov Data Platform  ·  Case Study — Viewpoint  ·  Akash Pahilwan</a:t>
+              <a:t>OpenGov Data Platform  ·  Case Study  ·  Akash Pahilwan</a:t>
             </a:r>
           </a:p>
         </p:txBody>
@@ -24604,7 +24604,7 @@
                 </a:solidFill>
                 <a:latin typeface="Segoe UI"/>
               </a:rPr>
-              <a:t>dbt for many domains — without a monolith</a:t>
+              <a:t>dbt for many domains, without a monolith</a:t>
             </a:r>
           </a:p>
         </p:txBody>
@@ -24688,7 +24688,7 @@
                 </a:solidFill>
                 <a:latin typeface="Segoe UI"/>
               </a:rPr>
-              <a:t>staging (1:1 with source) → intermediate → marts (by domain).</a:t>
+              <a:t>Staging (1:1 with source) → intermediate → marts (by domain).</a:t>
             </a:r>
           </a:p>
           <a:p>
@@ -24725,7 +24725,7 @@
                 </a:solidFill>
                 <a:latin typeface="Segoe UI"/>
               </a:rPr>
-              <a:t>folders + CODEOWNERS per domain (revops, finance, product, hr).</a:t>
+              <a:t>Folders + CODEOWNERS per domain (revops, finance, product, hr).</a:t>
             </a:r>
           </a:p>
           <a:p>
@@ -24762,7 +24762,7 @@
                 </a:solidFill>
                 <a:latin typeface="Segoe UI"/>
               </a:rPr>
-              <a:t>each domain exposes PUBLIC models via contracts; consumers depend on stable interfaces, not internals.</a:t>
+              <a:t>Each domain exposes PUBLIC models via contracts; consumers depend on stable interfaces, not internals.</a:t>
             </a:r>
           </a:p>
           <a:p>
@@ -24799,7 +24799,7 @@
                 </a:solidFill>
                 <a:latin typeface="Segoe UI"/>
               </a:rPr>
-              <a:t>generic + singular tests, model contracts, source freshness, exposures for BI/AI lineage.</a:t>
+              <a:t>Generic + singular tests, model contracts, source freshness, exposures for BI/AI lineage.</a:t>
             </a:r>
           </a:p>
           <a:p>
@@ -24836,7 +24836,7 @@
                 </a:solidFill>
                 <a:latin typeface="Segoe UI"/>
               </a:rPr>
-              <a:t>incremental for high-volume events (telemetry); full-refresh for small dimensions.</a:t>
+              <a:t>Incremental for high-volume events (telemetry); full-refresh for small dimensions.</a:t>
             </a:r>
           </a:p>
           <a:p>
@@ -24873,7 +24873,7 @@
                 </a:solidFill>
                 <a:latin typeface="Segoe UI"/>
               </a:rPr>
-              <a:t>slim CI builds only state:modified+ — seconds, not full rebuilds.</a:t>
+              <a:t>Slim CI builds only state:modified+, seconds, not full rebuilds.</a:t>
             </a:r>
           </a:p>
         </p:txBody>
@@ -25038,7 +25038,7 @@
                 </a:solidFill>
                 <a:latin typeface="Segoe UI"/>
               </a:rPr>
-              <a:t>OpenGov Data Platform  ·  Case Study — Viewpoint  ·  Akash Pahilwan</a:t>
+              <a:t>OpenGov Data Platform  ·  Case Study  ·  Akash Pahilwan</a:t>
             </a:r>
           </a:p>
         </p:txBody>
@@ -25312,7 +25312,7 @@
                 </a:solidFill>
                 <a:latin typeface="Segoe UI"/>
               </a:rPr>
-              <a:t>One Terraform module — domain_workspace:   </a:t>
+              <a:t>One Terraform module, domain_workspace:   </a:t>
             </a:r>
             <a:r>
               <a:rPr sz="1800">
@@ -25321,7 +25321,7 @@
                 </a:solidFill>
                 <a:latin typeface="Segoe UI"/>
               </a:rPr>
-              <a:t>input a domain name, get a full, governed workspace.</a:t>
+              <a:t>Input a domain name, get a full, governed workspace.</a:t>
             </a:r>
           </a:p>
           <a:p>
@@ -25340,7 +25340,7 @@
                 </a:solidFill>
                 <a:latin typeface="Segoe UI"/>
               </a:rPr>
-              <a:t>        –  </a:t>
+              <a:t>        ·  </a:t>
             </a:r>
             <a:r>
               <a:rPr b="1" sz="1500">
@@ -25358,7 +25358,7 @@
                 </a:solidFill>
                 <a:latin typeface="Segoe UI"/>
               </a:rPr>
-              <a:t>schemas (staging / marts / sandbox), functional + access roles, service accounts, a warehouse.</a:t>
+              <a:t>Schemas (staging / marts / sandbox), functional + access roles, service accounts, a warehouse.</a:t>
             </a:r>
           </a:p>
           <a:p>
@@ -25377,7 +25377,7 @@
                 </a:solidFill>
                 <a:latin typeface="Segoe UI"/>
               </a:rPr>
-              <a:t>        –  </a:t>
+              <a:t>        ·  </a:t>
             </a:r>
             <a:r>
               <a:rPr b="1" sz="1500">
@@ -25395,7 +25395,7 @@
                 </a:solidFill>
                 <a:latin typeface="Segoe UI"/>
               </a:rPr>
-              <a:t>default grants, PII tags, cost limits, and naming standards automatically.</a:t>
+              <a:t>Default grants, PII tags, cost limits, and naming standards automatically.</a:t>
             </a:r>
           </a:p>
           <a:p>
@@ -25432,7 +25432,7 @@
                 </a:solidFill>
                 <a:latin typeface="Segoe UI"/>
               </a:rPr>
-              <a:t>starter dbt project, connector config, and CI workflow scaffolded for the team.</a:t>
+              <a:t>Starter dbt project, connector config, and CI workflow scaffolded for the team.</a:t>
             </a:r>
           </a:p>
           <a:p>
@@ -25469,7 +25469,7 @@
                 </a:solidFill>
                 <a:latin typeface="Segoe UI"/>
               </a:rPr>
-              <a:t>a domain is onboarded by opening a PR — reviewed, planned, applied by CI. No tickets.</a:t>
+              <a:t>A domain is onboarded by opening a PR, reviewed, planned, applied by CI. No tickets.</a:t>
             </a:r>
           </a:p>
           <a:p>
@@ -25506,7 +25506,7 @@
                 </a:solidFill>
                 <a:latin typeface="Segoe UI"/>
               </a:rPr>
-              <a:t>consistent and governed by construction; hours, not weeks; the platform team doesn't become the bottleneck.</a:t>
+              <a:t>Consistent and governed by construction; hours, not weeks; the platform team doesn't become the bottleneck.</a:t>
             </a:r>
           </a:p>
         </p:txBody>
@@ -25637,7 +25637,7 @@
                 </a:solidFill>
                 <a:latin typeface="Segoe UI"/>
               </a:rPr>
-              <a:t>The paved path makes the governed way the easiest way — self-service without losing control.</a:t>
+              <a:t>The paved path makes the governed way the easiest way, self-service without losing control.</a:t>
             </a:r>
           </a:p>
         </p:txBody>
@@ -25671,7 +25671,7 @@
                 </a:solidFill>
                 <a:latin typeface="Segoe UI"/>
               </a:rPr>
-              <a:t>OpenGov Data Platform  ·  Case Study — Viewpoint  ·  Akash Pahilwan</a:t>
+              <a:t>OpenGov Data Platform  ·  Case Study  ·  Akash Pahilwan</a:t>
             </a:r>
           </a:p>
         </p:txBody>

</xml_diff>

<commit_message>
Deck: persist manual edits; reflect SANDBOX access model; README layout
Persist edits made in the .pptx into build_deck.py:
- slide 5: "...one layer down(If needed)."
- slide 7: "MARTS → SANDBOX(Ideal)"
- slide 8: "source freshness(ideal)"
- slide 9: dropped "cost limits,"
- slide 11: dropped the POLICY_REFERENCES clause
Also: slide 7 SANDBOX sub-bullet now states the real access (analyst-writable;
readers/developers read-only; admin full), and README layout lists SANDBOX.

Co-Authored-By: Claude Opus 4.8 (1M context) <noreply@anthropic.com>
</commit_message>
<xml_diff>
--- a/presentation/OpenGov_Data_Platform_CaseStudy.pptx
+++ b/presentation/OpenGov_Data_Platform_CaseStudy.pptx
@@ -7371,7 +7371,7 @@
                 </a:solidFill>
                 <a:latin typeface="Segoe UI"/>
               </a:rPr>
-              <a:t>COPY_HISTORY (14d) for loads, ACCESS_HISTORY (365d) for 'who read ACCOUNT.ARR, when', POLICY_REFERENCES to prove the mask was attached.</a:t>
+              <a:t>COPY_HISTORY (14d) for loads, ACCESS_HISTORY (365d) for 'who read ACCOUNT.ARR, when'.</a:t>
             </a:r>
           </a:p>
           <a:p>
@@ -24160,7 +24160,7 @@
                 </a:solidFill>
                 <a:latin typeface="Segoe UI"/>
               </a:rPr>
-              <a:t>It types columns and ALTERs its own RAW tables on drift; the dbt source contract + tests are our CI tripwire one layer down.</a:t>
+              <a:t>It types columns and ALTERs its own RAW tables on drift; the dbt source contract + tests are our CI tripwire one layer down(If needed).</a:t>
             </a:r>
           </a:p>
         </p:txBody>
@@ -25665,7 +25665,7 @@
                 </a:solidFill>
                 <a:latin typeface="Segoe UI"/>
               </a:rPr>
-              <a:t>RAW → STAGING → MARTS → SANDBOX; clear ownership and blast-radius per layer.</a:t>
+              <a:t>RAW → STAGING → MARTS → SANDBOX(Ideal); clear ownership and blast-radius per layer.</a:t>
             </a:r>
           </a:p>
           <a:p>
@@ -25813,7 +25813,7 @@
                 </a:solidFill>
                 <a:latin typeface="Segoe UI"/>
               </a:rPr>
-              <a:t>Analyst scratch; safe to break, no downstream dependencies.</a:t>
+              <a:t>Analyst-writable scratch; readers &amp; developers read-only, admin full; safe to break, no downstream deps.</a:t>
             </a:r>
           </a:p>
           <a:p>
@@ -26446,7 +26446,7 @@
                 </a:solidFill>
                 <a:latin typeface="Segoe UI"/>
               </a:rPr>
-              <a:t>Generic + singular tests, model contracts, source freshness, exposures for BI/AI lineage.</a:t>
+              <a:t>Generic + singular tests, model contracts, source freshness(ideal), exposures for BI/AI lineage.</a:t>
             </a:r>
           </a:p>
           <a:p>
@@ -27042,7 +27042,7 @@
                 </a:solidFill>
                 <a:latin typeface="Segoe UI"/>
               </a:rPr>
-              <a:t>Default grants, PII tags, cost limits, and naming standards automatically.</a:t>
+              <a:t>Default grants, PII tags, and naming standards automatically.</a:t>
             </a:r>
           </a:p>
           <a:p>

</xml_diff>

<commit_message>
Deck: add database-per-layer + dedicated SANDBOX to Future Enhancements
Keep the "(Ideal)" markers on the architecture slides AND represent each in the
roadmap. Fast CI (state:modified) and dbt source freshness were already in the
Future Enhancements section; add the database-per-layer + dedicated SANDBOX
aspiration (the SANDBOX(Ideal) marker) under governance/isolation.

Co-Authored-By: Claude Opus 4.8 (1M context) <noreply@anthropic.com>
</commit_message>
<xml_diff>
--- a/presentation/OpenGov_Data_Platform_CaseStudy.pptx
+++ b/presentation/OpenGov_Data_Platform_CaseStudy.pptx
@@ -14759,8 +14759,8 @@
         </p:nvSpPr>
         <p:spPr>
           <a:xfrm>
-            <a:off x="640080" y="1325880"/>
-            <a:ext cx="10972800" cy="4434840"/>
+            <a:off x="640080" y="1280160"/>
+            <a:ext cx="10972800" cy="4526280"/>
           </a:xfrm>
           <a:prstGeom prst="rect">
             <a:avLst/>
@@ -14782,7 +14782,7 @@
               </a:spcAft>
             </a:pPr>
             <a:r>
-              <a:rPr sz="1550">
+              <a:rPr sz="1500">
                 <a:solidFill>
                   <a:srgbClr val="4A3FFF"/>
                 </a:solidFill>
@@ -14791,7 +14791,7 @@
               <a:t>▸  </a:t>
             </a:r>
             <a:r>
-              <a:rPr b="1" sz="1550">
+              <a:rPr b="1" sz="1500">
                 <a:solidFill>
                   <a:srgbClr val="1B1B33"/>
                 </a:solidFill>
@@ -14810,7 +14810,7 @@
               </a:spcAft>
             </a:pPr>
             <a:r>
-              <a:rPr sz="1250">
+              <a:rPr sz="1200">
                 <a:solidFill>
                   <a:srgbClr val="5C5B77"/>
                 </a:solidFill>
@@ -14819,7 +14819,7 @@
               <a:t>        ·  </a:t>
             </a:r>
             <a:r>
-              <a:rPr b="1" sz="1250">
+              <a:rPr b="1" sz="1200">
                 <a:solidFill>
                   <a:srgbClr val="1B1B33"/>
                 </a:solidFill>
@@ -14828,7 +14828,7 @@
               <a:t>Snowpipe auto-ingest   </a:t>
             </a:r>
             <a:r>
-              <a:rPr sz="1250">
+              <a:rPr sz="1200">
                 <a:solidFill>
                   <a:srgbClr val="3E3D5C"/>
                 </a:solidFill>
@@ -14847,7 +14847,7 @@
               </a:spcAft>
             </a:pPr>
             <a:r>
-              <a:rPr sz="1250">
+              <a:rPr sz="1200">
                 <a:solidFill>
                   <a:srgbClr val="5C5B77"/>
                 </a:solidFill>
@@ -14856,7 +14856,7 @@
               <a:t>        ·  </a:t>
             </a:r>
             <a:r>
-              <a:rPr b="1" sz="1250">
+              <a:rPr b="1" sz="1200">
                 <a:solidFill>
                   <a:srgbClr val="1B1B33"/>
                 </a:solidFill>
@@ -14865,7 +14865,7 @@
               <a:t>Config-driven multi-event framework   </a:t>
             </a:r>
             <a:r>
-              <a:rPr sz="1250">
+              <a:rPr sz="1200">
                 <a:solidFill>
                   <a:srgbClr val="3E3D5C"/>
                 </a:solidFill>
@@ -14884,7 +14884,7 @@
               </a:spcAft>
             </a:pPr>
             <a:r>
-              <a:rPr sz="1550">
+              <a:rPr sz="1500">
                 <a:solidFill>
                   <a:srgbClr val="4A3FFF"/>
                 </a:solidFill>
@@ -14893,7 +14893,7 @@
               <a:t>▸  </a:t>
             </a:r>
             <a:r>
-              <a:rPr b="1" sz="1550">
+              <a:rPr b="1" sz="1500">
                 <a:solidFill>
                   <a:srgbClr val="1B1B33"/>
                 </a:solidFill>
@@ -14912,7 +14912,7 @@
               </a:spcAft>
             </a:pPr>
             <a:r>
-              <a:rPr sz="1250">
+              <a:rPr sz="1200">
                 <a:solidFill>
                   <a:srgbClr val="5C5B77"/>
                 </a:solidFill>
@@ -14921,7 +14921,7 @@
               <a:t>        ·  </a:t>
             </a:r>
             <a:r>
-              <a:rPr b="1" sz="1250">
+              <a:rPr b="1" sz="1200">
                 <a:solidFill>
                   <a:srgbClr val="1B1B33"/>
                 </a:solidFill>
@@ -14930,7 +14930,7 @@
               <a:t>Slim CI (state:modified)   </a:t>
             </a:r>
             <a:r>
-              <a:rPr sz="1250">
+              <a:rPr sz="1200">
                 <a:solidFill>
                   <a:srgbClr val="3E3D5C"/>
                 </a:solidFill>
@@ -14949,7 +14949,7 @@
               </a:spcAft>
             </a:pPr>
             <a:r>
-              <a:rPr sz="1250">
+              <a:rPr sz="1200">
                 <a:solidFill>
                   <a:srgbClr val="5C5B77"/>
                 </a:solidFill>
@@ -14958,7 +14958,7 @@
               <a:t>        ·  </a:t>
             </a:r>
             <a:r>
-              <a:rPr b="1" sz="1250">
+              <a:rPr b="1" sz="1200">
                 <a:solidFill>
                   <a:srgbClr val="1B1B33"/>
                 </a:solidFill>
@@ -14967,7 +14967,7 @@
               <a:t>Domain spoke repos   </a:t>
             </a:r>
             <a:r>
-              <a:rPr sz="1250">
+              <a:rPr sz="1200">
                 <a:solidFill>
                   <a:srgbClr val="3E3D5C"/>
                 </a:solidFill>
@@ -14986,7 +14986,7 @@
               </a:spcAft>
             </a:pPr>
             <a:r>
-              <a:rPr sz="1550">
+              <a:rPr sz="1500">
                 <a:solidFill>
                   <a:srgbClr val="4A3FFF"/>
                 </a:solidFill>
@@ -14995,7 +14995,7 @@
               <a:t>▸  </a:t>
             </a:r>
             <a:r>
-              <a:rPr b="1" sz="1550">
+              <a:rPr b="1" sz="1500">
                 <a:solidFill>
                   <a:srgbClr val="1B1B33"/>
                 </a:solidFill>
@@ -15014,7 +15014,7 @@
               </a:spcAft>
             </a:pPr>
             <a:r>
-              <a:rPr sz="1250">
+              <a:rPr sz="1200">
                 <a:solidFill>
                   <a:srgbClr val="5C5B77"/>
                 </a:solidFill>
@@ -15023,7 +15023,7 @@
               <a:t>        ·  </a:t>
             </a:r>
             <a:r>
-              <a:rPr b="1" sz="1250">
+              <a:rPr b="1" sz="1200">
                 <a:solidFill>
                   <a:srgbClr val="1B1B33"/>
                 </a:solidFill>
@@ -15032,7 +15032,7 @@
               <a:t>Row-access policies   </a:t>
             </a:r>
             <a:r>
-              <a:rPr sz="1250">
+              <a:rPr sz="1200">
                 <a:solidFill>
                   <a:srgbClr val="3E3D5C"/>
                 </a:solidFill>
@@ -15051,7 +15051,7 @@
               </a:spcAft>
             </a:pPr>
             <a:r>
-              <a:rPr sz="1250">
+              <a:rPr sz="1200">
                 <a:solidFill>
                   <a:srgbClr val="5C5B77"/>
                 </a:solidFill>
@@ -15060,7 +15060,7 @@
               <a:t>        ·  </a:t>
             </a:r>
             <a:r>
-              <a:rPr b="1" sz="1250">
+              <a:rPr b="1" sz="1200">
                 <a:solidFill>
                   <a:srgbClr val="1B1B33"/>
                 </a:solidFill>
@@ -15069,13 +15069,50 @@
               <a:t>OIDC federated CI auth   </a:t>
             </a:r>
             <a:r>
-              <a:rPr sz="1250">
+              <a:rPr sz="1200">
                 <a:solidFill>
                   <a:srgbClr val="3E3D5C"/>
                 </a:solidFill>
                 <a:latin typeface="Segoe UI"/>
               </a:rPr>
               <a:t>Retire long-lived key-pairs; env-specific DEV_* / PROD_* role split for per-env isolation.</a:t>
+            </a:r>
+          </a:p>
+          <a:p>
+            <a:pPr>
+              <a:lnSpc>
+                <a:spcPct val="107000"/>
+              </a:lnSpc>
+              <a:spcAft>
+                <a:spcPts val="300"/>
+              </a:spcAft>
+            </a:pPr>
+            <a:r>
+              <a:rPr sz="1200">
+                <a:solidFill>
+                  <a:srgbClr val="5C5B77"/>
+                </a:solidFill>
+                <a:latin typeface="Segoe UI"/>
+              </a:rPr>
+              <a:t>        ·  </a:t>
+            </a:r>
+            <a:r>
+              <a:rPr b="1" sz="1200">
+                <a:solidFill>
+                  <a:srgbClr val="1B1B33"/>
+                </a:solidFill>
+                <a:latin typeface="Segoe UI"/>
+              </a:rPr>
+              <a:t>Database-per-layer + dedicated SANDBOX   </a:t>
+            </a:r>
+            <a:r>
+              <a:rPr sz="1200">
+                <a:solidFill>
+                  <a:srgbClr val="3E3D5C"/>
+                </a:solidFill>
+                <a:latin typeface="Segoe UI"/>
+              </a:rPr>
+              <a:t>RAW / STAGING / MARTS / SANDBOX as separate databases (today: schema-per-layer, one DB per env).</a:t>
             </a:r>
           </a:p>
         </p:txBody>

</xml_diff>